<commit_message>
adding tex link to homeworks page
</commit_message>
<xml_diff>
--- a/slides/00-DailyAnnouncements.pptx
+++ b/slides/00-DailyAnnouncements.pptx
@@ -5,7 +5,7 @@
     <p:sldMasterId id="2147484006" r:id="rId1"/>
   </p:sldMasterIdLst>
   <p:notesMasterIdLst>
-    <p:notesMasterId r:id="rId13"/>
+    <p:notesMasterId r:id="rId14"/>
   </p:notesMasterIdLst>
   <p:sldIdLst>
     <p:sldId id="256" r:id="rId2"/>
@@ -18,7 +18,8 @@
     <p:sldId id="521" r:id="rId9"/>
     <p:sldId id="522" r:id="rId10"/>
     <p:sldId id="523" r:id="rId11"/>
-    <p:sldId id="515" r:id="rId12"/>
+    <p:sldId id="524" r:id="rId12"/>
+    <p:sldId id="515" r:id="rId13"/>
   </p:sldIdLst>
   <p:sldSz cx="12192000" cy="6858000"/>
   <p:notesSz cx="6858000" cy="9144000"/>
@@ -207,7 +208,7 @@
           <a:p>
             <a:fld id="{C5B45307-6ED4-B142-BD64-10F739779302}" type="datetimeFigureOut">
               <a:rPr lang="en-US" smtClean="0"/>
-              <a:t>9/15/26</a:t>
+              <a:t>9/21/26</a:t>
             </a:fld>
             <a:endParaRPr lang="en-US"/>
           </a:p>
@@ -615,7 +616,7 @@
           <a:noFill/>
           <a:extLst>
             <a:ext uri="{909E8E84-426E-40dd-AFC4-6F175D3DCCD1}">
-              <a14:hiddenFill xmlns="" xmlns:a14="http://schemas.microsoft.com/office/drawing/2010/main">
+              <a14:hiddenFill xmlns:a14="http://schemas.microsoft.com/office/drawing/2010/main" xmlns="">
                 <a:solidFill>
                   <a:srgbClr val="FFFFFF"/>
                 </a:solidFill>
@@ -674,7 +675,7 @@
             </a:ln>
             <a:extLst>
               <a:ext uri="{91240B29-F687-4f45-9708-019B960494DF}">
-                <a14:hiddenLine xmlns="" xmlns:a14="http://schemas.microsoft.com/office/drawing/2010/main" w="9525">
+                <a14:hiddenLine xmlns:a14="http://schemas.microsoft.com/office/drawing/2010/main" xmlns="" w="9525">
                   <a:solidFill>
                     <a:srgbClr val="000000"/>
                   </a:solidFill>
@@ -764,7 +765,7 @@
             </a:ln>
             <a:extLst>
               <a:ext uri="{91240B29-F687-4f45-9708-019B960494DF}">
-                <a14:hiddenLine xmlns="" xmlns:a14="http://schemas.microsoft.com/office/drawing/2010/main" w="9525">
+                <a14:hiddenLine xmlns:a14="http://schemas.microsoft.com/office/drawing/2010/main" xmlns="" w="9525">
                   <a:solidFill>
                     <a:srgbClr val="000000"/>
                   </a:solidFill>
@@ -854,7 +855,7 @@
             </a:ln>
             <a:extLst>
               <a:ext uri="{91240B29-F687-4f45-9708-019B960494DF}">
-                <a14:hiddenLine xmlns="" xmlns:a14="http://schemas.microsoft.com/office/drawing/2010/main" w="9525">
+                <a14:hiddenLine xmlns:a14="http://schemas.microsoft.com/office/drawing/2010/main" xmlns="" w="9525">
                   <a:solidFill>
                     <a:srgbClr val="000000"/>
                   </a:solidFill>
@@ -888,7 +889,7 @@
             </a:ln>
             <a:extLst>
               <a:ext uri="{91240B29-F687-4f45-9708-019B960494DF}">
-                <a14:hiddenLine xmlns="" xmlns:a14="http://schemas.microsoft.com/office/drawing/2010/main" w="9525">
+                <a14:hiddenLine xmlns:a14="http://schemas.microsoft.com/office/drawing/2010/main" xmlns="" w="9525">
                   <a:solidFill>
                     <a:srgbClr val="000000"/>
                   </a:solidFill>
@@ -978,7 +979,7 @@
             </a:ln>
             <a:extLst>
               <a:ext uri="{91240B29-F687-4f45-9708-019B960494DF}">
-                <a14:hiddenLine xmlns="" xmlns:a14="http://schemas.microsoft.com/office/drawing/2010/main" w="9525">
+                <a14:hiddenLine xmlns:a14="http://schemas.microsoft.com/office/drawing/2010/main" xmlns="" w="9525">
                   <a:solidFill>
                     <a:srgbClr val="000000"/>
                   </a:solidFill>
@@ -1040,7 +1041,7 @@
             </a:ln>
             <a:extLst>
               <a:ext uri="{91240B29-F687-4f45-9708-019B960494DF}">
-                <a14:hiddenLine xmlns="" xmlns:a14="http://schemas.microsoft.com/office/drawing/2010/main" w="9525">
+                <a14:hiddenLine xmlns:a14="http://schemas.microsoft.com/office/drawing/2010/main" xmlns="" w="9525">
                   <a:solidFill>
                     <a:srgbClr val="000000"/>
                   </a:solidFill>
@@ -1102,7 +1103,7 @@
             </a:ln>
             <a:extLst>
               <a:ext uri="{91240B29-F687-4f45-9708-019B960494DF}">
-                <a14:hiddenLine xmlns="" xmlns:a14="http://schemas.microsoft.com/office/drawing/2010/main" w="9525">
+                <a14:hiddenLine xmlns:a14="http://schemas.microsoft.com/office/drawing/2010/main" xmlns="" w="9525">
                   <a:solidFill>
                     <a:srgbClr val="000000"/>
                   </a:solidFill>
@@ -1192,7 +1193,7 @@
             </a:ln>
             <a:extLst>
               <a:ext uri="{91240B29-F687-4f45-9708-019B960494DF}">
-                <a14:hiddenLine xmlns="" xmlns:a14="http://schemas.microsoft.com/office/drawing/2010/main" w="9525">
+                <a14:hiddenLine xmlns:a14="http://schemas.microsoft.com/office/drawing/2010/main" xmlns="" w="9525">
                   <a:solidFill>
                     <a:srgbClr val="000000"/>
                   </a:solidFill>
@@ -1254,7 +1255,7 @@
             </a:ln>
             <a:extLst>
               <a:ext uri="{91240B29-F687-4f45-9708-019B960494DF}">
-                <a14:hiddenLine xmlns="" xmlns:a14="http://schemas.microsoft.com/office/drawing/2010/main" w="9525">
+                <a14:hiddenLine xmlns:a14="http://schemas.microsoft.com/office/drawing/2010/main" xmlns="" w="9525">
                   <a:solidFill>
                     <a:srgbClr val="000000"/>
                   </a:solidFill>
@@ -1316,7 +1317,7 @@
             </a:ln>
             <a:extLst>
               <a:ext uri="{91240B29-F687-4f45-9708-019B960494DF}">
-                <a14:hiddenLine xmlns="" xmlns:a14="http://schemas.microsoft.com/office/drawing/2010/main" w="9525">
+                <a14:hiddenLine xmlns:a14="http://schemas.microsoft.com/office/drawing/2010/main" xmlns="" w="9525">
                   <a:solidFill>
                     <a:srgbClr val="000000"/>
                   </a:solidFill>
@@ -1406,7 +1407,7 @@
             </a:ln>
             <a:extLst>
               <a:ext uri="{91240B29-F687-4f45-9708-019B960494DF}">
-                <a14:hiddenLine xmlns="" xmlns:a14="http://schemas.microsoft.com/office/drawing/2010/main" w="9525">
+                <a14:hiddenLine xmlns:a14="http://schemas.microsoft.com/office/drawing/2010/main" xmlns="" w="9525">
                   <a:solidFill>
                     <a:srgbClr val="000000"/>
                   </a:solidFill>
@@ -1496,7 +1497,7 @@
             </a:ln>
             <a:extLst>
               <a:ext uri="{91240B29-F687-4f45-9708-019B960494DF}">
-                <a14:hiddenLine xmlns="" xmlns:a14="http://schemas.microsoft.com/office/drawing/2010/main" w="9525">
+                <a14:hiddenLine xmlns:a14="http://schemas.microsoft.com/office/drawing/2010/main" xmlns="" w="9525">
                   <a:solidFill>
                     <a:srgbClr val="000000"/>
                   </a:solidFill>
@@ -1558,7 +1559,7 @@
             </a:ln>
             <a:extLst>
               <a:ext uri="{91240B29-F687-4f45-9708-019B960494DF}">
-                <a14:hiddenLine xmlns="" xmlns:a14="http://schemas.microsoft.com/office/drawing/2010/main" w="9525">
+                <a14:hiddenLine xmlns:a14="http://schemas.microsoft.com/office/drawing/2010/main" xmlns="" w="9525">
                   <a:solidFill>
                     <a:srgbClr val="000000"/>
                   </a:solidFill>
@@ -1668,7 +1669,7 @@
             </a:ln>
             <a:extLst>
               <a:ext uri="{91240B29-F687-4f45-9708-019B960494DF}">
-                <a14:hiddenLine xmlns="" xmlns:a14="http://schemas.microsoft.com/office/drawing/2010/main" w="9525">
+                <a14:hiddenLine xmlns:a14="http://schemas.microsoft.com/office/drawing/2010/main" xmlns="" w="9525">
                   <a:solidFill>
                     <a:srgbClr val="000000"/>
                   </a:solidFill>
@@ -1730,7 +1731,7 @@
             </a:ln>
             <a:extLst>
               <a:ext uri="{91240B29-F687-4f45-9708-019B960494DF}">
-                <a14:hiddenLine xmlns="" xmlns:a14="http://schemas.microsoft.com/office/drawing/2010/main" w="9525">
+                <a14:hiddenLine xmlns:a14="http://schemas.microsoft.com/office/drawing/2010/main" xmlns="" w="9525">
                   <a:solidFill>
                     <a:srgbClr val="000000"/>
                   </a:solidFill>
@@ -1820,7 +1821,7 @@
             </a:ln>
             <a:extLst>
               <a:ext uri="{91240B29-F687-4f45-9708-019B960494DF}">
-                <a14:hiddenLine xmlns="" xmlns:a14="http://schemas.microsoft.com/office/drawing/2010/main" w="9525">
+                <a14:hiddenLine xmlns:a14="http://schemas.microsoft.com/office/drawing/2010/main" xmlns="" w="9525">
                   <a:solidFill>
                     <a:srgbClr val="000000"/>
                   </a:solidFill>
@@ -1910,7 +1911,7 @@
             </a:ln>
             <a:extLst>
               <a:ext uri="{91240B29-F687-4f45-9708-019B960494DF}">
-                <a14:hiddenLine xmlns="" xmlns:a14="http://schemas.microsoft.com/office/drawing/2010/main" w="9525">
+                <a14:hiddenLine xmlns:a14="http://schemas.microsoft.com/office/drawing/2010/main" xmlns="" w="9525">
                   <a:solidFill>
                     <a:srgbClr val="000000"/>
                   </a:solidFill>
@@ -1972,7 +1973,7 @@
             </a:ln>
             <a:extLst>
               <a:ext uri="{91240B29-F687-4f45-9708-019B960494DF}">
-                <a14:hiddenLine xmlns="" xmlns:a14="http://schemas.microsoft.com/office/drawing/2010/main" w="9525">
+                <a14:hiddenLine xmlns:a14="http://schemas.microsoft.com/office/drawing/2010/main" xmlns="" w="9525">
                   <a:solidFill>
                     <a:srgbClr val="000000"/>
                   </a:solidFill>
@@ -2062,7 +2063,7 @@
             </a:ln>
             <a:extLst>
               <a:ext uri="{91240B29-F687-4f45-9708-019B960494DF}">
-                <a14:hiddenLine xmlns="" xmlns:a14="http://schemas.microsoft.com/office/drawing/2010/main" w="9525">
+                <a14:hiddenLine xmlns:a14="http://schemas.microsoft.com/office/drawing/2010/main" xmlns="" w="9525">
                   <a:solidFill>
                     <a:srgbClr val="000000"/>
                   </a:solidFill>
@@ -2152,7 +2153,7 @@
             </a:ln>
             <a:extLst>
               <a:ext uri="{91240B29-F687-4f45-9708-019B960494DF}">
-                <a14:hiddenLine xmlns="" xmlns:a14="http://schemas.microsoft.com/office/drawing/2010/main" w="9525">
+                <a14:hiddenLine xmlns:a14="http://schemas.microsoft.com/office/drawing/2010/main" xmlns="" w="9525">
                   <a:solidFill>
                     <a:srgbClr val="000000"/>
                   </a:solidFill>
@@ -2208,7 +2209,7 @@
             </a:ln>
             <a:extLst>
               <a:ext uri="{91240B29-F687-4f45-9708-019B960494DF}">
-                <a14:hiddenLine xmlns="" xmlns:a14="http://schemas.microsoft.com/office/drawing/2010/main" w="9525">
+                <a14:hiddenLine xmlns:a14="http://schemas.microsoft.com/office/drawing/2010/main" xmlns="" w="9525">
                   <a:solidFill>
                     <a:srgbClr val="000000"/>
                   </a:solidFill>
@@ -2298,7 +2299,7 @@
             </a:ln>
             <a:extLst>
               <a:ext uri="{91240B29-F687-4f45-9708-019B960494DF}">
-                <a14:hiddenLine xmlns="" xmlns:a14="http://schemas.microsoft.com/office/drawing/2010/main" w="9525">
+                <a14:hiddenLine xmlns:a14="http://schemas.microsoft.com/office/drawing/2010/main" xmlns="" w="9525">
                   <a:solidFill>
                     <a:srgbClr val="000000"/>
                   </a:solidFill>
@@ -2354,7 +2355,7 @@
             </a:ln>
             <a:extLst>
               <a:ext uri="{91240B29-F687-4f45-9708-019B960494DF}">
-                <a14:hiddenLine xmlns="" xmlns:a14="http://schemas.microsoft.com/office/drawing/2010/main" w="9525">
+                <a14:hiddenLine xmlns:a14="http://schemas.microsoft.com/office/drawing/2010/main" xmlns="" w="9525">
                   <a:solidFill>
                     <a:srgbClr val="000000"/>
                   </a:solidFill>
@@ -2444,7 +2445,7 @@
             </a:ln>
             <a:extLst>
               <a:ext uri="{91240B29-F687-4f45-9708-019B960494DF}">
-                <a14:hiddenLine xmlns="" xmlns:a14="http://schemas.microsoft.com/office/drawing/2010/main" w="9525">
+                <a14:hiddenLine xmlns:a14="http://schemas.microsoft.com/office/drawing/2010/main" xmlns="" w="9525">
                   <a:solidFill>
                     <a:srgbClr val="000000"/>
                   </a:solidFill>
@@ -2512,7 +2513,7 @@
             </a:ln>
             <a:extLst>
               <a:ext uri="{91240B29-F687-4f45-9708-019B960494DF}">
-                <a14:hiddenLine xmlns="" xmlns:a14="http://schemas.microsoft.com/office/drawing/2010/main" w="9525">
+                <a14:hiddenLine xmlns:a14="http://schemas.microsoft.com/office/drawing/2010/main" xmlns="" w="9525">
                   <a:solidFill>
                     <a:srgbClr val="000000"/>
                   </a:solidFill>
@@ -2602,7 +2603,7 @@
             </a:ln>
             <a:extLst>
               <a:ext uri="{91240B29-F687-4f45-9708-019B960494DF}">
-                <a14:hiddenLine xmlns="" xmlns:a14="http://schemas.microsoft.com/office/drawing/2010/main" w="9525">
+                <a14:hiddenLine xmlns:a14="http://schemas.microsoft.com/office/drawing/2010/main" xmlns="" w="9525">
                   <a:solidFill>
                     <a:srgbClr val="000000"/>
                   </a:solidFill>
@@ -2670,7 +2671,7 @@
             </a:ln>
             <a:extLst>
               <a:ext uri="{91240B29-F687-4f45-9708-019B960494DF}">
-                <a14:hiddenLine xmlns="" xmlns:a14="http://schemas.microsoft.com/office/drawing/2010/main" w="9525">
+                <a14:hiddenLine xmlns:a14="http://schemas.microsoft.com/office/drawing/2010/main" xmlns="" w="9525">
                   <a:solidFill>
                     <a:srgbClr val="000000"/>
                   </a:solidFill>
@@ -2760,7 +2761,7 @@
             </a:ln>
             <a:extLst>
               <a:ext uri="{91240B29-F687-4f45-9708-019B960494DF}">
-                <a14:hiddenLine xmlns="" xmlns:a14="http://schemas.microsoft.com/office/drawing/2010/main" w="9525">
+                <a14:hiddenLine xmlns:a14="http://schemas.microsoft.com/office/drawing/2010/main" xmlns="" w="9525">
                   <a:solidFill>
                     <a:srgbClr val="000000"/>
                   </a:solidFill>
@@ -2794,7 +2795,7 @@
             </a:ln>
             <a:extLst>
               <a:ext uri="{91240B29-F687-4f45-9708-019B960494DF}">
-                <a14:hiddenLine xmlns="" xmlns:a14="http://schemas.microsoft.com/office/drawing/2010/main" w="9525">
+                <a14:hiddenLine xmlns:a14="http://schemas.microsoft.com/office/drawing/2010/main" xmlns="" w="9525">
                   <a:solidFill>
                     <a:srgbClr val="000000"/>
                   </a:solidFill>
@@ -2884,7 +2885,7 @@
             </a:ln>
             <a:extLst>
               <a:ext uri="{91240B29-F687-4f45-9708-019B960494DF}">
-                <a14:hiddenLine xmlns="" xmlns:a14="http://schemas.microsoft.com/office/drawing/2010/main" w="9525">
+                <a14:hiddenLine xmlns:a14="http://schemas.microsoft.com/office/drawing/2010/main" xmlns="" w="9525">
                   <a:solidFill>
                     <a:srgbClr val="000000"/>
                   </a:solidFill>
@@ -2946,7 +2947,7 @@
             </a:ln>
             <a:extLst>
               <a:ext uri="{91240B29-F687-4f45-9708-019B960494DF}">
-                <a14:hiddenLine xmlns="" xmlns:a14="http://schemas.microsoft.com/office/drawing/2010/main" w="9525">
+                <a14:hiddenLine xmlns:a14="http://schemas.microsoft.com/office/drawing/2010/main" xmlns="" w="9525">
                   <a:solidFill>
                     <a:srgbClr val="000000"/>
                   </a:solidFill>
@@ -3008,7 +3009,7 @@
             </a:ln>
             <a:extLst>
               <a:ext uri="{91240B29-F687-4f45-9708-019B960494DF}">
-                <a14:hiddenLine xmlns="" xmlns:a14="http://schemas.microsoft.com/office/drawing/2010/main" w="9525">
+                <a14:hiddenLine xmlns:a14="http://schemas.microsoft.com/office/drawing/2010/main" xmlns="" w="9525">
                   <a:solidFill>
                     <a:srgbClr val="000000"/>
                   </a:solidFill>
@@ -3098,7 +3099,7 @@
             </a:ln>
             <a:extLst>
               <a:ext uri="{91240B29-F687-4f45-9708-019B960494DF}">
-                <a14:hiddenLine xmlns="" xmlns:a14="http://schemas.microsoft.com/office/drawing/2010/main" w="9525">
+                <a14:hiddenLine xmlns:a14="http://schemas.microsoft.com/office/drawing/2010/main" xmlns="" w="9525">
                   <a:solidFill>
                     <a:srgbClr val="000000"/>
                   </a:solidFill>
@@ -3166,7 +3167,7 @@
             </a:ln>
             <a:extLst>
               <a:ext uri="{91240B29-F687-4f45-9708-019B960494DF}">
-                <a14:hiddenLine xmlns="" xmlns:a14="http://schemas.microsoft.com/office/drawing/2010/main" w="9525">
+                <a14:hiddenLine xmlns:a14="http://schemas.microsoft.com/office/drawing/2010/main" xmlns="" w="9525">
                   <a:solidFill>
                     <a:srgbClr val="000000"/>
                   </a:solidFill>
@@ -3228,7 +3229,7 @@
             </a:ln>
             <a:extLst>
               <a:ext uri="{91240B29-F687-4f45-9708-019B960494DF}">
-                <a14:hiddenLine xmlns="" xmlns:a14="http://schemas.microsoft.com/office/drawing/2010/main" w="9525">
+                <a14:hiddenLine xmlns:a14="http://schemas.microsoft.com/office/drawing/2010/main" xmlns="" w="9525">
                   <a:solidFill>
                     <a:srgbClr val="000000"/>
                   </a:solidFill>
@@ -3318,7 +3319,7 @@
             </a:ln>
             <a:extLst>
               <a:ext uri="{91240B29-F687-4f45-9708-019B960494DF}">
-                <a14:hiddenLine xmlns="" xmlns:a14="http://schemas.microsoft.com/office/drawing/2010/main" w="9525">
+                <a14:hiddenLine xmlns:a14="http://schemas.microsoft.com/office/drawing/2010/main" xmlns="" w="9525">
                   <a:solidFill>
                     <a:srgbClr val="000000"/>
                   </a:solidFill>
@@ -3380,7 +3381,7 @@
             </a:ln>
             <a:extLst>
               <a:ext uri="{91240B29-F687-4f45-9708-019B960494DF}">
-                <a14:hiddenLine xmlns="" xmlns:a14="http://schemas.microsoft.com/office/drawing/2010/main" w="9525">
+                <a14:hiddenLine xmlns:a14="http://schemas.microsoft.com/office/drawing/2010/main" xmlns="" w="9525">
                   <a:solidFill>
                     <a:srgbClr val="000000"/>
                   </a:solidFill>
@@ -3470,7 +3471,7 @@
             </a:ln>
             <a:extLst>
               <a:ext uri="{91240B29-F687-4f45-9708-019B960494DF}">
-                <a14:hiddenLine xmlns="" xmlns:a14="http://schemas.microsoft.com/office/drawing/2010/main" w="9525">
+                <a14:hiddenLine xmlns:a14="http://schemas.microsoft.com/office/drawing/2010/main" xmlns="" w="9525">
                   <a:solidFill>
                     <a:srgbClr val="000000"/>
                   </a:solidFill>
@@ -3532,7 +3533,7 @@
             </a:ln>
             <a:extLst>
               <a:ext uri="{91240B29-F687-4f45-9708-019B960494DF}">
-                <a14:hiddenLine xmlns="" xmlns:a14="http://schemas.microsoft.com/office/drawing/2010/main" w="9525">
+                <a14:hiddenLine xmlns:a14="http://schemas.microsoft.com/office/drawing/2010/main" xmlns="" w="9525">
                   <a:solidFill>
                     <a:srgbClr val="000000"/>
                   </a:solidFill>
@@ -3622,7 +3623,7 @@
             </a:ln>
             <a:extLst>
               <a:ext uri="{91240B29-F687-4f45-9708-019B960494DF}">
-                <a14:hiddenLine xmlns="" xmlns:a14="http://schemas.microsoft.com/office/drawing/2010/main" w="9525">
+                <a14:hiddenLine xmlns:a14="http://schemas.microsoft.com/office/drawing/2010/main" xmlns="" w="9525">
                   <a:solidFill>
                     <a:srgbClr val="000000"/>
                   </a:solidFill>
@@ -3656,7 +3657,7 @@
             </a:ln>
             <a:extLst>
               <a:ext uri="{91240B29-F687-4f45-9708-019B960494DF}">
-                <a14:hiddenLine xmlns="" xmlns:a14="http://schemas.microsoft.com/office/drawing/2010/main" w="9525">
+                <a14:hiddenLine xmlns:a14="http://schemas.microsoft.com/office/drawing/2010/main" xmlns="" w="9525">
                   <a:solidFill>
                     <a:srgbClr val="000000"/>
                   </a:solidFill>
@@ -3721,7 +3722,7 @@
             </a:ln>
             <a:extLst>
               <a:ext uri="{91240B29-F687-4f45-9708-019B960494DF}">
-                <a14:hiddenLine xmlns="" xmlns:a14="http://schemas.microsoft.com/office/drawing/2010/main" w="9525">
+                <a14:hiddenLine xmlns:a14="http://schemas.microsoft.com/office/drawing/2010/main" xmlns="" w="9525">
                   <a:solidFill>
                     <a:srgbClr val="000000"/>
                   </a:solidFill>
@@ -3811,7 +3812,7 @@
             </a:ln>
             <a:extLst>
               <a:ext uri="{91240B29-F687-4f45-9708-019B960494DF}">
-                <a14:hiddenLine xmlns="" xmlns:a14="http://schemas.microsoft.com/office/drawing/2010/main" w="9525">
+                <a14:hiddenLine xmlns:a14="http://schemas.microsoft.com/office/drawing/2010/main" xmlns="" w="9525">
                   <a:solidFill>
                     <a:srgbClr val="000000"/>
                   </a:solidFill>
@@ -3873,7 +3874,7 @@
             </a:ln>
             <a:extLst>
               <a:ext uri="{91240B29-F687-4f45-9708-019B960494DF}">
-                <a14:hiddenLine xmlns="" xmlns:a14="http://schemas.microsoft.com/office/drawing/2010/main" w="9525">
+                <a14:hiddenLine xmlns:a14="http://schemas.microsoft.com/office/drawing/2010/main" xmlns="" w="9525">
                   <a:solidFill>
                     <a:srgbClr val="000000"/>
                   </a:solidFill>
@@ -3963,7 +3964,7 @@
             </a:ln>
             <a:extLst>
               <a:ext uri="{91240B29-F687-4f45-9708-019B960494DF}">
-                <a14:hiddenLine xmlns="" xmlns:a14="http://schemas.microsoft.com/office/drawing/2010/main" w="9525">
+                <a14:hiddenLine xmlns:a14="http://schemas.microsoft.com/office/drawing/2010/main" xmlns="" w="9525">
                   <a:solidFill>
                     <a:srgbClr val="000000"/>
                   </a:solidFill>
@@ -4053,7 +4054,7 @@
             </a:ln>
             <a:extLst>
               <a:ext uri="{91240B29-F687-4f45-9708-019B960494DF}">
-                <a14:hiddenLine xmlns="" xmlns:a14="http://schemas.microsoft.com/office/drawing/2010/main" w="9525">
+                <a14:hiddenLine xmlns:a14="http://schemas.microsoft.com/office/drawing/2010/main" xmlns="" w="9525">
                   <a:solidFill>
                     <a:srgbClr val="000000"/>
                   </a:solidFill>
@@ -4118,7 +4119,7 @@
             </a:ln>
             <a:extLst>
               <a:ext uri="{91240B29-F687-4f45-9708-019B960494DF}">
-                <a14:hiddenLine xmlns="" xmlns:a14="http://schemas.microsoft.com/office/drawing/2010/main" w="9525">
+                <a14:hiddenLine xmlns:a14="http://schemas.microsoft.com/office/drawing/2010/main" xmlns="" w="9525">
                   <a:solidFill>
                     <a:srgbClr val="000000"/>
                   </a:solidFill>
@@ -4180,7 +4181,7 @@
             </a:ln>
             <a:extLst>
               <a:ext uri="{91240B29-F687-4f45-9708-019B960494DF}">
-                <a14:hiddenLine xmlns="" xmlns:a14="http://schemas.microsoft.com/office/drawing/2010/main" w="9525">
+                <a14:hiddenLine xmlns:a14="http://schemas.microsoft.com/office/drawing/2010/main" xmlns="" w="9525">
                   <a:solidFill>
                     <a:srgbClr val="000000"/>
                   </a:solidFill>
@@ -4270,7 +4271,7 @@
             </a:ln>
             <a:extLst>
               <a:ext uri="{91240B29-F687-4f45-9708-019B960494DF}">
-                <a14:hiddenLine xmlns="" xmlns:a14="http://schemas.microsoft.com/office/drawing/2010/main" w="9525">
+                <a14:hiddenLine xmlns:a14="http://schemas.microsoft.com/office/drawing/2010/main" xmlns="" w="9525">
                   <a:solidFill>
                     <a:srgbClr val="000000"/>
                   </a:solidFill>
@@ -4360,7 +4361,7 @@
             </a:ln>
             <a:extLst>
               <a:ext uri="{91240B29-F687-4f45-9708-019B960494DF}">
-                <a14:hiddenLine xmlns="" xmlns:a14="http://schemas.microsoft.com/office/drawing/2010/main" w="9525">
+                <a14:hiddenLine xmlns:a14="http://schemas.microsoft.com/office/drawing/2010/main" xmlns="" w="9525">
                   <a:solidFill>
                     <a:srgbClr val="000000"/>
                   </a:solidFill>
@@ -4422,7 +4423,7 @@
             </a:ln>
             <a:extLst>
               <a:ext uri="{91240B29-F687-4f45-9708-019B960494DF}">
-                <a14:hiddenLine xmlns="" xmlns:a14="http://schemas.microsoft.com/office/drawing/2010/main" w="9525">
+                <a14:hiddenLine xmlns:a14="http://schemas.microsoft.com/office/drawing/2010/main" xmlns="" w="9525">
                   <a:solidFill>
                     <a:srgbClr val="000000"/>
                   </a:solidFill>
@@ -4542,7 +4543,7 @@
             </a:ln>
             <a:extLst>
               <a:ext uri="{91240B29-F687-4f45-9708-019B960494DF}">
-                <a14:hiddenLine xmlns="" xmlns:a14="http://schemas.microsoft.com/office/drawing/2010/main" w="9525">
+                <a14:hiddenLine xmlns:a14="http://schemas.microsoft.com/office/drawing/2010/main" xmlns="" w="9525">
                   <a:solidFill>
                     <a:srgbClr val="000000"/>
                   </a:solidFill>
@@ -4610,7 +4611,7 @@
             </a:ln>
             <a:extLst>
               <a:ext uri="{91240B29-F687-4f45-9708-019B960494DF}">
-                <a14:hiddenLine xmlns="" xmlns:a14="http://schemas.microsoft.com/office/drawing/2010/main" w="9525">
+                <a14:hiddenLine xmlns:a14="http://schemas.microsoft.com/office/drawing/2010/main" xmlns="" w="9525">
                   <a:solidFill>
                     <a:srgbClr val="000000"/>
                   </a:solidFill>
@@ -4700,7 +4701,7 @@
             </a:ln>
             <a:extLst>
               <a:ext uri="{91240B29-F687-4f45-9708-019B960494DF}">
-                <a14:hiddenLine xmlns="" xmlns:a14="http://schemas.microsoft.com/office/drawing/2010/main" w="9525">
+                <a14:hiddenLine xmlns:a14="http://schemas.microsoft.com/office/drawing/2010/main" xmlns="" w="9525">
                   <a:solidFill>
                     <a:srgbClr val="000000"/>
                   </a:solidFill>
@@ -4840,7 +4841,7 @@
           <a:p>
             <a:fld id="{4313F670-7F9A-774D-B73D-573401E44297}" type="datetime1">
               <a:rPr lang="en-US" smtClean="0"/>
-              <a:t>9/15/26</a:t>
+              <a:t>9/21/26</a:t>
             </a:fld>
             <a:endParaRPr lang="en-US"/>
           </a:p>
@@ -5107,7 +5108,7 @@
           <a:p>
             <a:fld id="{446F9669-A8A7-2D40-9D01-B35FC337AA30}" type="datetime1">
               <a:rPr lang="en-US" smtClean="0"/>
-              <a:t>9/15/26</a:t>
+              <a:t>9/21/26</a:t>
             </a:fld>
             <a:endParaRPr lang="en-US"/>
           </a:p>
@@ -5303,7 +5304,7 @@
           <a:p>
             <a:fld id="{FA76CF18-F41B-6B48-B3E5-599E9795C2C3}" type="datetime1">
               <a:rPr lang="en-US" smtClean="0"/>
-              <a:t>9/15/26</a:t>
+              <a:t>9/21/26</a:t>
             </a:fld>
             <a:endParaRPr lang="en-US"/>
           </a:p>
@@ -5566,7 +5567,7 @@
           <a:p>
             <a:fld id="{B9654854-6457-164F-A077-6B3035079B82}" type="datetime1">
               <a:rPr lang="en-US" smtClean="0"/>
-              <a:t>9/15/26</a:t>
+              <a:t>9/21/26</a:t>
             </a:fld>
             <a:endParaRPr lang="en-US"/>
           </a:p>
@@ -6000,7 +6001,7 @@
           <a:p>
             <a:fld id="{CE3DBFD7-E611-8C40-AC73-0C29FF63F0CD}" type="datetime1">
               <a:rPr lang="en-US" smtClean="0"/>
-              <a:t>9/15/26</a:t>
+              <a:t>9/21/26</a:t>
             </a:fld>
             <a:endParaRPr lang="en-US"/>
           </a:p>
@@ -6546,7 +6547,7 @@
           <a:p>
             <a:fld id="{C8B63B06-0493-2840-9F37-30C9412BBF17}" type="datetime1">
               <a:rPr lang="en-US" smtClean="0"/>
-              <a:t>9/15/26</a:t>
+              <a:t>9/21/26</a:t>
             </a:fld>
             <a:endParaRPr lang="en-US"/>
           </a:p>
@@ -7266,7 +7267,7 @@
           <a:p>
             <a:fld id="{72B5C0FA-8C46-E84D-B6D7-B673F2CA0A0E}" type="datetime1">
               <a:rPr lang="en-US" smtClean="0"/>
-              <a:t>9/15/26</a:t>
+              <a:t>9/21/26</a:t>
             </a:fld>
             <a:endParaRPr lang="en-US"/>
           </a:p>
@@ -7436,7 +7437,7 @@
           <a:p>
             <a:fld id="{60B9CDE1-97B4-BF46-B69C-B86855B18820}" type="datetime1">
               <a:rPr lang="en-US" smtClean="0"/>
-              <a:t>9/15/26</a:t>
+              <a:t>9/21/26</a:t>
             </a:fld>
             <a:endParaRPr lang="en-US"/>
           </a:p>
@@ -7616,7 +7617,7 @@
           <a:p>
             <a:fld id="{BE51D3A4-F9E5-FD49-AA87-B395F50451DC}" type="datetime1">
               <a:rPr lang="en-US" smtClean="0"/>
-              <a:t>9/15/26</a:t>
+              <a:t>9/21/26</a:t>
             </a:fld>
             <a:endParaRPr lang="en-US"/>
           </a:p>
@@ -7786,7 +7787,7 @@
           <a:p>
             <a:fld id="{880DFB37-B0AE-9449-85EC-14F9C83B6084}" type="datetime1">
               <a:rPr lang="en-US" smtClean="0"/>
-              <a:t>9/15/26</a:t>
+              <a:t>9/21/26</a:t>
             </a:fld>
             <a:endParaRPr lang="en-US"/>
           </a:p>
@@ -8036,7 +8037,7 @@
           <a:p>
             <a:fld id="{C939124A-616E-6944-A21A-1839F5DBE7BB}" type="datetime1">
               <a:rPr lang="en-US" smtClean="0"/>
-              <a:t>9/15/26</a:t>
+              <a:t>9/21/26</a:t>
             </a:fld>
             <a:endParaRPr lang="en-US"/>
           </a:p>
@@ -8268,7 +8269,7 @@
           <a:p>
             <a:fld id="{C6E9A026-D48C-FD43-8676-CD625DD5D84B}" type="datetime1">
               <a:rPr lang="en-US" smtClean="0"/>
-              <a:t>9/15/26</a:t>
+              <a:t>9/21/26</a:t>
             </a:fld>
             <a:endParaRPr lang="en-US"/>
           </a:p>
@@ -8654,7 +8655,7 @@
           <a:p>
             <a:fld id="{EA35111E-23A3-1440-99A3-C4C665908E3D}" type="datetime1">
               <a:rPr lang="en-US" smtClean="0"/>
-              <a:t>9/15/26</a:t>
+              <a:t>9/21/26</a:t>
             </a:fld>
             <a:endParaRPr lang="en-US"/>
           </a:p>
@@ -8777,7 +8778,7 @@
           <a:p>
             <a:fld id="{249983B9-88EF-D74B-BA6D-6A3BF17C2B38}" type="datetime1">
               <a:rPr lang="en-US" smtClean="0"/>
-              <a:t>9/15/26</a:t>
+              <a:t>9/21/26</a:t>
             </a:fld>
             <a:endParaRPr lang="en-US"/>
           </a:p>
@@ -8872,7 +8873,7 @@
           <a:p>
             <a:fld id="{E2A00AEF-B4EC-084A-8DB8-A225C7981CBB}" type="datetime1">
               <a:rPr lang="en-US" smtClean="0"/>
-              <a:t>9/15/26</a:t>
+              <a:t>9/21/26</a:t>
             </a:fld>
             <a:endParaRPr lang="en-US"/>
           </a:p>
@@ -9121,7 +9122,7 @@
           <a:p>
             <a:fld id="{97860299-21CD-A94A-A7B0-44E787F8D42C}" type="datetime1">
               <a:rPr lang="en-US" smtClean="0"/>
-              <a:t>9/15/26</a:t>
+              <a:t>9/21/26</a:t>
             </a:fld>
             <a:endParaRPr lang="en-US"/>
           </a:p>
@@ -9406,7 +9407,7 @@
           <a:p>
             <a:fld id="{3DFD19CF-4E62-D246-BA61-7B528271315F}" type="datetime1">
               <a:rPr lang="en-US" smtClean="0"/>
-              <a:t>9/15/26</a:t>
+              <a:t>9/21/26</a:t>
             </a:fld>
             <a:endParaRPr lang="en-US"/>
           </a:p>
@@ -9529,7 +9530,7 @@
           <a:noFill/>
           <a:extLst>
             <a:ext uri="{909E8E84-426E-40dd-AFC4-6F175D3DCCD1}">
-              <a14:hiddenFill xmlns="" xmlns:a14="http://schemas.microsoft.com/office/drawing/2010/main">
+              <a14:hiddenFill xmlns:a14="http://schemas.microsoft.com/office/drawing/2010/main" xmlns="">
                 <a:solidFill>
                   <a:srgbClr val="FFFFFF"/>
                 </a:solidFill>
@@ -9603,7 +9604,7 @@
               </a:ln>
               <a:extLst>
                 <a:ext uri="{91240B29-F687-4f45-9708-019B960494DF}">
-                  <a14:hiddenLine xmlns="" xmlns:a14="http://schemas.microsoft.com/office/drawing/2010/main" w="9525">
+                  <a14:hiddenLine xmlns:a14="http://schemas.microsoft.com/office/drawing/2010/main" xmlns="" w="9525">
                     <a:solidFill>
                       <a:srgbClr val="000000"/>
                     </a:solidFill>
@@ -9693,7 +9694,7 @@
               </a:ln>
               <a:extLst>
                 <a:ext uri="{91240B29-F687-4f45-9708-019B960494DF}">
-                  <a14:hiddenLine xmlns="" xmlns:a14="http://schemas.microsoft.com/office/drawing/2010/main" w="9525">
+                  <a14:hiddenLine xmlns:a14="http://schemas.microsoft.com/office/drawing/2010/main" xmlns="" w="9525">
                     <a:solidFill>
                       <a:srgbClr val="000000"/>
                     </a:solidFill>
@@ -9783,7 +9784,7 @@
               </a:ln>
               <a:extLst>
                 <a:ext uri="{91240B29-F687-4f45-9708-019B960494DF}">
-                  <a14:hiddenLine xmlns="" xmlns:a14="http://schemas.microsoft.com/office/drawing/2010/main" w="9525">
+                  <a14:hiddenLine xmlns:a14="http://schemas.microsoft.com/office/drawing/2010/main" xmlns="" w="9525">
                     <a:solidFill>
                       <a:srgbClr val="000000"/>
                     </a:solidFill>
@@ -9845,7 +9846,7 @@
               </a:ln>
               <a:extLst>
                 <a:ext uri="{91240B29-F687-4f45-9708-019B960494DF}">
-                  <a14:hiddenLine xmlns="" xmlns:a14="http://schemas.microsoft.com/office/drawing/2010/main" w="9525">
+                  <a14:hiddenLine xmlns:a14="http://schemas.microsoft.com/office/drawing/2010/main" xmlns="" w="9525">
                     <a:solidFill>
                       <a:srgbClr val="000000"/>
                     </a:solidFill>
@@ -9935,7 +9936,7 @@
               </a:ln>
               <a:extLst>
                 <a:ext uri="{91240B29-F687-4f45-9708-019B960494DF}">
-                  <a14:hiddenLine xmlns="" xmlns:a14="http://schemas.microsoft.com/office/drawing/2010/main" w="9525">
+                  <a14:hiddenLine xmlns:a14="http://schemas.microsoft.com/office/drawing/2010/main" xmlns="" w="9525">
                     <a:solidFill>
                       <a:srgbClr val="000000"/>
                     </a:solidFill>
@@ -9997,7 +9998,7 @@
               </a:ln>
               <a:extLst>
                 <a:ext uri="{91240B29-F687-4f45-9708-019B960494DF}">
-                  <a14:hiddenLine xmlns="" xmlns:a14="http://schemas.microsoft.com/office/drawing/2010/main" w="9525">
+                  <a14:hiddenLine xmlns:a14="http://schemas.microsoft.com/office/drawing/2010/main" xmlns="" w="9525">
                     <a:solidFill>
                       <a:srgbClr val="000000"/>
                     </a:solidFill>
@@ -10059,7 +10060,7 @@
               </a:ln>
               <a:extLst>
                 <a:ext uri="{91240B29-F687-4f45-9708-019B960494DF}">
-                  <a14:hiddenLine xmlns="" xmlns:a14="http://schemas.microsoft.com/office/drawing/2010/main" w="9525">
+                  <a14:hiddenLine xmlns:a14="http://schemas.microsoft.com/office/drawing/2010/main" xmlns="" w="9525">
                     <a:solidFill>
                       <a:srgbClr val="000000"/>
                     </a:solidFill>
@@ -10149,7 +10150,7 @@
               </a:ln>
               <a:extLst>
                 <a:ext uri="{91240B29-F687-4f45-9708-019B960494DF}">
-                  <a14:hiddenLine xmlns="" xmlns:a14="http://schemas.microsoft.com/office/drawing/2010/main" w="9525">
+                  <a14:hiddenLine xmlns:a14="http://schemas.microsoft.com/office/drawing/2010/main" xmlns="" w="9525">
                     <a:solidFill>
                       <a:srgbClr val="000000"/>
                     </a:solidFill>
@@ -10239,7 +10240,7 @@
               </a:ln>
               <a:extLst>
                 <a:ext uri="{91240B29-F687-4f45-9708-019B960494DF}">
-                  <a14:hiddenLine xmlns="" xmlns:a14="http://schemas.microsoft.com/office/drawing/2010/main" w="9525">
+                  <a14:hiddenLine xmlns:a14="http://schemas.microsoft.com/office/drawing/2010/main" xmlns="" w="9525">
                     <a:solidFill>
                       <a:srgbClr val="000000"/>
                     </a:solidFill>
@@ -10301,7 +10302,7 @@
               </a:ln>
               <a:extLst>
                 <a:ext uri="{91240B29-F687-4f45-9708-019B960494DF}">
-                  <a14:hiddenLine xmlns="" xmlns:a14="http://schemas.microsoft.com/office/drawing/2010/main" w="9525">
+                  <a14:hiddenLine xmlns:a14="http://schemas.microsoft.com/office/drawing/2010/main" xmlns="" w="9525">
                     <a:solidFill>
                       <a:srgbClr val="000000"/>
                     </a:solidFill>
@@ -10411,7 +10412,7 @@
               </a:ln>
               <a:extLst>
                 <a:ext uri="{91240B29-F687-4f45-9708-019B960494DF}">
-                  <a14:hiddenLine xmlns="" xmlns:a14="http://schemas.microsoft.com/office/drawing/2010/main" w="9525">
+                  <a14:hiddenLine xmlns:a14="http://schemas.microsoft.com/office/drawing/2010/main" xmlns="" w="9525">
                     <a:solidFill>
                       <a:srgbClr val="000000"/>
                     </a:solidFill>
@@ -10495,7 +10496,7 @@
               </a:ln>
               <a:extLst>
                 <a:ext uri="{91240B29-F687-4f45-9708-019B960494DF}">
-                  <a14:hiddenLine xmlns="" xmlns:a14="http://schemas.microsoft.com/office/drawing/2010/main" w="9525">
+                  <a14:hiddenLine xmlns:a14="http://schemas.microsoft.com/office/drawing/2010/main" xmlns="" w="9525">
                     <a:solidFill>
                       <a:srgbClr val="000000"/>
                     </a:solidFill>
@@ -10557,7 +10558,7 @@
               </a:ln>
               <a:extLst>
                 <a:ext uri="{91240B29-F687-4f45-9708-019B960494DF}">
-                  <a14:hiddenLine xmlns="" xmlns:a14="http://schemas.microsoft.com/office/drawing/2010/main" w="9525">
+                  <a14:hiddenLine xmlns:a14="http://schemas.microsoft.com/office/drawing/2010/main" xmlns="" w="9525">
                     <a:solidFill>
                       <a:srgbClr val="000000"/>
                     </a:solidFill>
@@ -10619,7 +10620,7 @@
               </a:ln>
               <a:extLst>
                 <a:ext uri="{91240B29-F687-4f45-9708-019B960494DF}">
-                  <a14:hiddenLine xmlns="" xmlns:a14="http://schemas.microsoft.com/office/drawing/2010/main" w="9525">
+                  <a14:hiddenLine xmlns:a14="http://schemas.microsoft.com/office/drawing/2010/main" xmlns="" w="9525">
                     <a:solidFill>
                       <a:srgbClr val="000000"/>
                     </a:solidFill>
@@ -10709,7 +10710,7 @@
               </a:ln>
               <a:extLst>
                 <a:ext uri="{91240B29-F687-4f45-9708-019B960494DF}">
-                  <a14:hiddenLine xmlns="" xmlns:a14="http://schemas.microsoft.com/office/drawing/2010/main" w="9525">
+                  <a14:hiddenLine xmlns:a14="http://schemas.microsoft.com/office/drawing/2010/main" xmlns="" w="9525">
                     <a:solidFill>
                       <a:srgbClr val="000000"/>
                     </a:solidFill>
@@ -10743,7 +10744,7 @@
               </a:ln>
               <a:extLst>
                 <a:ext uri="{91240B29-F687-4f45-9708-019B960494DF}">
-                  <a14:hiddenLine xmlns="" xmlns:a14="http://schemas.microsoft.com/office/drawing/2010/main" w="9525">
+                  <a14:hiddenLine xmlns:a14="http://schemas.microsoft.com/office/drawing/2010/main" xmlns="" w="9525">
                     <a:solidFill>
                       <a:srgbClr val="000000"/>
                     </a:solidFill>
@@ -10808,7 +10809,7 @@
               </a:ln>
               <a:extLst>
                 <a:ext uri="{91240B29-F687-4f45-9708-019B960494DF}">
-                  <a14:hiddenLine xmlns="" xmlns:a14="http://schemas.microsoft.com/office/drawing/2010/main" w="9525">
+                  <a14:hiddenLine xmlns:a14="http://schemas.microsoft.com/office/drawing/2010/main" xmlns="" w="9525">
                     <a:solidFill>
                       <a:srgbClr val="000000"/>
                     </a:solidFill>
@@ -10898,7 +10899,7 @@
               </a:ln>
               <a:extLst>
                 <a:ext uri="{91240B29-F687-4f45-9708-019B960494DF}">
-                  <a14:hiddenLine xmlns="" xmlns:a14="http://schemas.microsoft.com/office/drawing/2010/main" w="9525">
+                  <a14:hiddenLine xmlns:a14="http://schemas.microsoft.com/office/drawing/2010/main" xmlns="" w="9525">
                     <a:solidFill>
                       <a:srgbClr val="000000"/>
                     </a:solidFill>
@@ -10960,7 +10961,7 @@
               </a:ln>
               <a:extLst>
                 <a:ext uri="{91240B29-F687-4f45-9708-019B960494DF}">
-                  <a14:hiddenLine xmlns="" xmlns:a14="http://schemas.microsoft.com/office/drawing/2010/main" w="9525">
+                  <a14:hiddenLine xmlns:a14="http://schemas.microsoft.com/office/drawing/2010/main" xmlns="" w="9525">
                     <a:solidFill>
                       <a:srgbClr val="000000"/>
                     </a:solidFill>
@@ -11050,7 +11051,7 @@
               </a:ln>
               <a:extLst>
                 <a:ext uri="{91240B29-F687-4f45-9708-019B960494DF}">
-                  <a14:hiddenLine xmlns="" xmlns:a14="http://schemas.microsoft.com/office/drawing/2010/main" w="9525">
+                  <a14:hiddenLine xmlns:a14="http://schemas.microsoft.com/office/drawing/2010/main" xmlns="" w="9525">
                     <a:solidFill>
                       <a:srgbClr val="000000"/>
                     </a:solidFill>
@@ -11115,7 +11116,7 @@
               </a:ln>
               <a:extLst>
                 <a:ext uri="{91240B29-F687-4f45-9708-019B960494DF}">
-                  <a14:hiddenLine xmlns="" xmlns:a14="http://schemas.microsoft.com/office/drawing/2010/main" w="9525">
+                  <a14:hiddenLine xmlns:a14="http://schemas.microsoft.com/office/drawing/2010/main" xmlns="" w="9525">
                     <a:solidFill>
                       <a:srgbClr val="000000"/>
                     </a:solidFill>
@@ -11177,7 +11178,7 @@
               </a:ln>
               <a:extLst>
                 <a:ext uri="{91240B29-F687-4f45-9708-019B960494DF}">
-                  <a14:hiddenLine xmlns="" xmlns:a14="http://schemas.microsoft.com/office/drawing/2010/main" w="9525">
+                  <a14:hiddenLine xmlns:a14="http://schemas.microsoft.com/office/drawing/2010/main" xmlns="" w="9525">
                     <a:solidFill>
                       <a:srgbClr val="000000"/>
                     </a:solidFill>
@@ -11267,7 +11268,7 @@
               </a:ln>
               <a:extLst>
                 <a:ext uri="{91240B29-F687-4f45-9708-019B960494DF}">
-                  <a14:hiddenLine xmlns="" xmlns:a14="http://schemas.microsoft.com/office/drawing/2010/main" w="9525">
+                  <a14:hiddenLine xmlns:a14="http://schemas.microsoft.com/office/drawing/2010/main" xmlns="" w="9525">
                     <a:solidFill>
                       <a:srgbClr val="000000"/>
                     </a:solidFill>
@@ -11357,7 +11358,7 @@
               </a:ln>
               <a:extLst>
                 <a:ext uri="{91240B29-F687-4f45-9708-019B960494DF}">
-                  <a14:hiddenLine xmlns="" xmlns:a14="http://schemas.microsoft.com/office/drawing/2010/main" w="9525">
+                  <a14:hiddenLine xmlns:a14="http://schemas.microsoft.com/office/drawing/2010/main" xmlns="" w="9525">
                     <a:solidFill>
                       <a:srgbClr val="000000"/>
                     </a:solidFill>
@@ -11422,7 +11423,7 @@
               </a:ln>
               <a:extLst>
                 <a:ext uri="{91240B29-F687-4f45-9708-019B960494DF}">
-                  <a14:hiddenLine xmlns="" xmlns:a14="http://schemas.microsoft.com/office/drawing/2010/main" w="9525">
+                  <a14:hiddenLine xmlns:a14="http://schemas.microsoft.com/office/drawing/2010/main" xmlns="" w="9525">
                     <a:solidFill>
                       <a:srgbClr val="000000"/>
                     </a:solidFill>
@@ -11542,7 +11543,7 @@
               </a:ln>
               <a:extLst>
                 <a:ext uri="{91240B29-F687-4f45-9708-019B960494DF}">
-                  <a14:hiddenLine xmlns="" xmlns:a14="http://schemas.microsoft.com/office/drawing/2010/main" w="9525">
+                  <a14:hiddenLine xmlns:a14="http://schemas.microsoft.com/office/drawing/2010/main" xmlns="" w="9525">
                     <a:solidFill>
                       <a:srgbClr val="000000"/>
                     </a:solidFill>
@@ -11623,7 +11624,7 @@
               </a:ln>
               <a:extLst>
                 <a:ext uri="{91240B29-F687-4f45-9708-019B960494DF}">
-                  <a14:hiddenLine xmlns="" xmlns:a14="http://schemas.microsoft.com/office/drawing/2010/main" w="9525">
+                  <a14:hiddenLine xmlns:a14="http://schemas.microsoft.com/office/drawing/2010/main" xmlns="" w="9525">
                     <a:solidFill>
                       <a:srgbClr val="000000"/>
                     </a:solidFill>
@@ -11738,7 +11739,7 @@
               </a:ln>
               <a:extLst>
                 <a:ext uri="{91240B29-F687-4f45-9708-019B960494DF}">
-                  <a14:hiddenLine xmlns="" xmlns:a14="http://schemas.microsoft.com/office/drawing/2010/main" w="9525">
+                  <a14:hiddenLine xmlns:a14="http://schemas.microsoft.com/office/drawing/2010/main" xmlns="" w="9525">
                     <a:solidFill>
                       <a:srgbClr val="000000"/>
                     </a:solidFill>
@@ -11828,7 +11829,7 @@
               </a:ln>
               <a:extLst>
                 <a:ext uri="{91240B29-F687-4f45-9708-019B960494DF}">
-                  <a14:hiddenLine xmlns="" xmlns:a14="http://schemas.microsoft.com/office/drawing/2010/main" w="9525">
+                  <a14:hiddenLine xmlns:a14="http://schemas.microsoft.com/office/drawing/2010/main" xmlns="" w="9525">
                     <a:solidFill>
                       <a:srgbClr val="000000"/>
                     </a:solidFill>
@@ -11893,7 +11894,7 @@
               </a:ln>
               <a:extLst>
                 <a:ext uri="{91240B29-F687-4f45-9708-019B960494DF}">
-                  <a14:hiddenLine xmlns="" xmlns:a14="http://schemas.microsoft.com/office/drawing/2010/main" w="9525">
+                  <a14:hiddenLine xmlns:a14="http://schemas.microsoft.com/office/drawing/2010/main" xmlns="" w="9525">
                     <a:solidFill>
                       <a:srgbClr val="000000"/>
                     </a:solidFill>
@@ -11983,7 +11984,7 @@
               </a:ln>
               <a:extLst>
                 <a:ext uri="{91240B29-F687-4f45-9708-019B960494DF}">
-                  <a14:hiddenLine xmlns="" xmlns:a14="http://schemas.microsoft.com/office/drawing/2010/main" w="9525">
+                  <a14:hiddenLine xmlns:a14="http://schemas.microsoft.com/office/drawing/2010/main" xmlns="" w="9525">
                     <a:solidFill>
                       <a:srgbClr val="000000"/>
                     </a:solidFill>
@@ -12051,7 +12052,7 @@
               </a:ln>
               <a:extLst>
                 <a:ext uri="{91240B29-F687-4f45-9708-019B960494DF}">
-                  <a14:hiddenLine xmlns="" xmlns:a14="http://schemas.microsoft.com/office/drawing/2010/main" w="9525">
+                  <a14:hiddenLine xmlns:a14="http://schemas.microsoft.com/office/drawing/2010/main" xmlns="" w="9525">
                     <a:solidFill>
                       <a:srgbClr val="000000"/>
                     </a:solidFill>
@@ -12141,7 +12142,7 @@
               </a:ln>
               <a:extLst>
                 <a:ext uri="{91240B29-F687-4f45-9708-019B960494DF}">
-                  <a14:hiddenLine xmlns="" xmlns:a14="http://schemas.microsoft.com/office/drawing/2010/main" w="9525">
+                  <a14:hiddenLine xmlns:a14="http://schemas.microsoft.com/office/drawing/2010/main" xmlns="" w="9525">
                     <a:solidFill>
                       <a:srgbClr val="000000"/>
                     </a:solidFill>
@@ -12209,7 +12210,7 @@
               </a:ln>
               <a:extLst>
                 <a:ext uri="{91240B29-F687-4f45-9708-019B960494DF}">
-                  <a14:hiddenLine xmlns="" xmlns:a14="http://schemas.microsoft.com/office/drawing/2010/main" w="9525">
+                  <a14:hiddenLine xmlns:a14="http://schemas.microsoft.com/office/drawing/2010/main" xmlns="" w="9525">
                     <a:solidFill>
                       <a:srgbClr val="000000"/>
                     </a:solidFill>
@@ -12299,7 +12300,7 @@
               </a:ln>
               <a:extLst>
                 <a:ext uri="{91240B29-F687-4f45-9708-019B960494DF}">
-                  <a14:hiddenLine xmlns="" xmlns:a14="http://schemas.microsoft.com/office/drawing/2010/main" w="9525">
+                  <a14:hiddenLine xmlns:a14="http://schemas.microsoft.com/office/drawing/2010/main" xmlns="" w="9525">
                     <a:solidFill>
                       <a:srgbClr val="000000"/>
                     </a:solidFill>
@@ -12333,7 +12334,7 @@
               </a:ln>
               <a:extLst>
                 <a:ext uri="{91240B29-F687-4f45-9708-019B960494DF}">
-                  <a14:hiddenLine xmlns="" xmlns:a14="http://schemas.microsoft.com/office/drawing/2010/main" w="9525">
+                  <a14:hiddenLine xmlns:a14="http://schemas.microsoft.com/office/drawing/2010/main" xmlns="" w="9525">
                     <a:solidFill>
                       <a:srgbClr val="000000"/>
                     </a:solidFill>
@@ -12473,7 +12474,7 @@
           <a:p>
             <a:fld id="{92FF8978-FE14-CC4A-93A6-934EB06543C0}" type="datetime1">
               <a:rPr lang="en-US" smtClean="0"/>
-              <a:t>9/15/26</a:t>
+              <a:t>9/21/26</a:t>
             </a:fld>
             <a:endParaRPr lang="en-US"/>
           </a:p>
@@ -13197,6 +13198,293 @@
   <p:cSld>
     <p:spTree>
       <p:nvGrpSpPr>
+        <p:cNvPr id="1" name="">
+          <a:extLst>
+            <a:ext uri="{FF2B5EF4-FFF2-40B4-BE49-F238E27FC236}">
+              <a16:creationId xmlns:a16="http://schemas.microsoft.com/office/drawing/2014/main" id="{9949C366-68C6-B99E-A0D0-678FDE6340E3}"/>
+            </a:ext>
+          </a:extLst>
+        </p:cNvPr>
+        <p:cNvGrpSpPr/>
+        <p:nvPr/>
+      </p:nvGrpSpPr>
+      <p:grpSpPr>
+        <a:xfrm>
+          <a:off x="0" y="0"/>
+          <a:ext cx="0" cy="0"/>
+          <a:chOff x="0" y="0"/>
+          <a:chExt cx="0" cy="0"/>
+        </a:xfrm>
+      </p:grpSpPr>
+      <p:sp>
+        <p:nvSpPr>
+          <p:cNvPr id="6146" name="Rectangle 2">
+            <a:extLst>
+              <a:ext uri="{FF2B5EF4-FFF2-40B4-BE49-F238E27FC236}">
+                <a16:creationId xmlns:a16="http://schemas.microsoft.com/office/drawing/2014/main" id="{C1217C3C-6FB3-06C0-0FD1-3530A32B8CC7}"/>
+              </a:ext>
+            </a:extLst>
+          </p:cNvPr>
+          <p:cNvSpPr>
+            <a:spLocks noGrp="1" noChangeArrowheads="1"/>
+          </p:cNvSpPr>
+          <p:nvPr>
+            <p:ph type="title"/>
+            <p:custDataLst>
+              <p:tags r:id="rId1"/>
+            </p:custDataLst>
+          </p:nvPr>
+        </p:nvSpPr>
+        <p:spPr>
+          <a:xfrm>
+            <a:off x="1141413" y="284084"/>
+            <a:ext cx="9905998" cy="620791"/>
+          </a:xfrm>
+        </p:spPr>
+        <p:txBody>
+          <a:bodyPr/>
+          <a:lstStyle/>
+          <a:p>
+            <a:pPr algn="ctr"/>
+            <a:r>
+              <a:rPr lang="en-US" dirty="0"/>
+              <a:t>Lecture 9 - Tuesday, Sep. 22</a:t>
+            </a:r>
+          </a:p>
+        </p:txBody>
+      </p:sp>
+      <p:sp>
+        <p:nvSpPr>
+          <p:cNvPr id="6147" name="Rectangle 3">
+            <a:extLst>
+              <a:ext uri="{FF2B5EF4-FFF2-40B4-BE49-F238E27FC236}">
+                <a16:creationId xmlns:a16="http://schemas.microsoft.com/office/drawing/2014/main" id="{1B64CE9E-5521-80ED-A7CE-CF16BF5644C9}"/>
+              </a:ext>
+            </a:extLst>
+          </p:cNvPr>
+          <p:cNvSpPr>
+            <a:spLocks noGrp="1" noChangeArrowheads="1"/>
+          </p:cNvSpPr>
+          <p:nvPr>
+            <p:ph idx="1"/>
+            <p:custDataLst>
+              <p:tags r:id="rId2"/>
+            </p:custDataLst>
+          </p:nvPr>
+        </p:nvSpPr>
+        <p:spPr>
+          <a:xfrm>
+            <a:off x="1294151" y="1098548"/>
+            <a:ext cx="9600522" cy="5475367"/>
+          </a:xfrm>
+        </p:spPr>
+        <p:txBody>
+          <a:bodyPr>
+            <a:normAutofit fontScale="70000" lnSpcReduction="20000"/>
+          </a:bodyPr>
+          <a:lstStyle/>
+          <a:p>
+            <a:r>
+              <a:rPr lang="en-US" dirty="0">
+                <a:latin typeface="Arial" panose="020B0604020202020204" pitchFamily="34" charset="0"/>
+                <a:cs typeface="Arial" panose="020B0604020202020204" pitchFamily="34" charset="0"/>
+              </a:rPr>
+              <a:t>Please remember </a:t>
+            </a:r>
+            <a:r>
+              <a:rPr lang="en-US" b="1" i="1" u="sng" dirty="0">
+                <a:latin typeface="Arial" panose="020B0604020202020204" pitchFamily="34" charset="0"/>
+                <a:cs typeface="Arial" panose="020B0604020202020204" pitchFamily="34" charset="0"/>
+              </a:rPr>
+              <a:t>no laptops / phones</a:t>
+            </a:r>
+            <a:r>
+              <a:rPr lang="en-US" dirty="0">
+                <a:latin typeface="Arial" panose="020B0604020202020204" pitchFamily="34" charset="0"/>
+                <a:cs typeface="Arial" panose="020B0604020202020204" pitchFamily="34" charset="0"/>
+              </a:rPr>
+              <a:t> and </a:t>
+            </a:r>
+            <a:r>
+              <a:rPr lang="en-US" b="1" i="1" u="sng" dirty="0">
+                <a:latin typeface="Arial" panose="020B0604020202020204" pitchFamily="34" charset="0"/>
+                <a:cs typeface="Arial" panose="020B0604020202020204" pitchFamily="34" charset="0"/>
+              </a:rPr>
+              <a:t>attendance policy</a:t>
+            </a:r>
+            <a:endParaRPr lang="en-US" dirty="0">
+              <a:latin typeface="Arial" panose="020B0604020202020204" pitchFamily="34" charset="0"/>
+              <a:cs typeface="Arial" panose="020B0604020202020204" pitchFamily="34" charset="0"/>
+            </a:endParaRPr>
+          </a:p>
+          <a:p>
+            <a:r>
+              <a:rPr lang="en-US" dirty="0">
+                <a:latin typeface="Arial" panose="020B0604020202020204" pitchFamily="34" charset="0"/>
+                <a:cs typeface="Arial" panose="020B0604020202020204" pitchFamily="34" charset="0"/>
+              </a:rPr>
+              <a:t>This week:</a:t>
+            </a:r>
+          </a:p>
+          <a:p>
+            <a:pPr lvl="1"/>
+            <a:r>
+              <a:rPr lang="en-US" dirty="0">
+                <a:latin typeface="Arial" panose="020B0604020202020204" pitchFamily="34" charset="0"/>
+                <a:cs typeface="Arial" panose="020B0604020202020204" pitchFamily="34" charset="0"/>
+              </a:rPr>
+              <a:t>Quiz 1 is </a:t>
+            </a:r>
+            <a:r>
+              <a:rPr lang="en-US" dirty="0" err="1">
+                <a:latin typeface="Arial" panose="020B0604020202020204" pitchFamily="34" charset="0"/>
+                <a:cs typeface="Arial" panose="020B0604020202020204" pitchFamily="34" charset="0"/>
+              </a:rPr>
+              <a:t>Mon,Tue,Wed</a:t>
+            </a:r>
+            <a:r>
+              <a:rPr lang="en-US" dirty="0">
+                <a:latin typeface="Arial" panose="020B0604020202020204" pitchFamily="34" charset="0"/>
+                <a:cs typeface="Arial" panose="020B0604020202020204" pitchFamily="34" charset="0"/>
+              </a:rPr>
+              <a:t> at CBTF (good luck!)</a:t>
+            </a:r>
+          </a:p>
+          <a:p>
+            <a:pPr lvl="1"/>
+            <a:r>
+              <a:rPr lang="en-US" dirty="0">
+                <a:latin typeface="Arial" panose="020B0604020202020204" pitchFamily="34" charset="0"/>
+                <a:cs typeface="Arial" panose="020B0604020202020204" pitchFamily="34" charset="0"/>
+              </a:rPr>
+              <a:t>Mod. 1 Programming Assignment is due this Thursday!</a:t>
+            </a:r>
+          </a:p>
+          <a:p>
+            <a:r>
+              <a:rPr lang="en-US" dirty="0">
+                <a:latin typeface="Arial" panose="020B0604020202020204" pitchFamily="34" charset="0"/>
+                <a:cs typeface="Arial" panose="020B0604020202020204" pitchFamily="34" charset="0"/>
+              </a:rPr>
+              <a:t>Module 1 Quiz</a:t>
+            </a:r>
+          </a:p>
+          <a:p>
+            <a:pPr lvl="1"/>
+            <a:r>
+              <a:rPr lang="en-US" dirty="0">
+                <a:latin typeface="Arial" panose="020B0604020202020204" pitchFamily="34" charset="0"/>
+                <a:cs typeface="Arial" panose="020B0604020202020204" pitchFamily="34" charset="0"/>
+              </a:rPr>
+              <a:t>Already completed it? How did it go? Any logistics issues or software bugs?</a:t>
+            </a:r>
+          </a:p>
+          <a:p>
+            <a:pPr lvl="1"/>
+            <a:r>
+              <a:rPr lang="en-US" dirty="0">
+                <a:latin typeface="Arial" panose="020B0604020202020204" pitchFamily="34" charset="0"/>
+                <a:cs typeface="Arial" panose="020B0604020202020204" pitchFamily="34" charset="0"/>
+              </a:rPr>
+              <a:t>Have not already taken it? Good luck! You got this!</a:t>
+            </a:r>
+          </a:p>
+          <a:p>
+            <a:pPr lvl="1"/>
+            <a:r>
+              <a:rPr lang="en-US" dirty="0">
+                <a:latin typeface="Arial" panose="020B0604020202020204" pitchFamily="34" charset="0"/>
+                <a:cs typeface="Arial" panose="020B0604020202020204" pitchFamily="34" charset="0"/>
+              </a:rPr>
+              <a:t>Everybody should have a reservation by now. If you don’t then you need to do that ASAP!</a:t>
+            </a:r>
+          </a:p>
+          <a:p>
+            <a:r>
+              <a:rPr lang="en-US" dirty="0">
+                <a:latin typeface="Arial" panose="020B0604020202020204" pitchFamily="34" charset="0"/>
+                <a:cs typeface="Arial" panose="020B0604020202020204" pitchFamily="34" charset="0"/>
+              </a:rPr>
+              <a:t>Mod. 1 homework is being graded right now. </a:t>
+            </a:r>
+          </a:p>
+          <a:p>
+            <a:pPr lvl="1"/>
+            <a:r>
+              <a:rPr lang="en-US" dirty="0">
+                <a:latin typeface="Arial" panose="020B0604020202020204" pitchFamily="34" charset="0"/>
+                <a:cs typeface="Arial" panose="020B0604020202020204" pitchFamily="34" charset="0"/>
+              </a:rPr>
+              <a:t>Looks like we generally won’t be able to get that back to you in time for quizzes due to the quick turnaround time. </a:t>
+            </a:r>
+          </a:p>
+          <a:p>
+            <a:pPr lvl="1"/>
+            <a:r>
+              <a:rPr lang="en-US" dirty="0">
+                <a:latin typeface="Arial" panose="020B0604020202020204" pitchFamily="34" charset="0"/>
+                <a:cs typeface="Arial" panose="020B0604020202020204" pitchFamily="34" charset="0"/>
+              </a:rPr>
+              <a:t>It is your responsibility to check your answers with others, use AI if necessary, or come to OH to talk to course staff to ensure you understand the concepts.</a:t>
+            </a:r>
+          </a:p>
+          <a:p>
+            <a:r>
+              <a:rPr lang="en-US" dirty="0">
+                <a:latin typeface="Arial" panose="020B0604020202020204" pitchFamily="34" charset="0"/>
+                <a:cs typeface="Arial" panose="020B0604020202020204" pitchFamily="34" charset="0"/>
+              </a:rPr>
+              <a:t>OH Check-Ins</a:t>
+            </a:r>
+          </a:p>
+          <a:p>
+            <a:pPr lvl="1"/>
+            <a:r>
+              <a:rPr lang="en-US" dirty="0">
+                <a:latin typeface="Arial" panose="020B0604020202020204" pitchFamily="34" charset="0"/>
+                <a:cs typeface="Arial" panose="020B0604020202020204" pitchFamily="34" charset="0"/>
+              </a:rPr>
+              <a:t>We have started working on the schedule for this. Stay tuned but be ready for this to begin very soon!</a:t>
+            </a:r>
+          </a:p>
+          <a:p>
+            <a:r>
+              <a:rPr lang="en-US" dirty="0">
+                <a:latin typeface="Arial" panose="020B0604020202020204" pitchFamily="34" charset="0"/>
+                <a:cs typeface="Arial" panose="020B0604020202020204" pitchFamily="34" charset="0"/>
+              </a:rPr>
+              <a:t>These slides are linked on the course webpage “slides” page.</a:t>
+            </a:r>
+          </a:p>
+          <a:p>
+            <a:r>
+              <a:rPr lang="en-US" dirty="0">
+                <a:latin typeface="Arial" panose="020B0604020202020204" pitchFamily="34" charset="0"/>
+                <a:cs typeface="Arial" panose="020B0604020202020204" pitchFamily="34" charset="0"/>
+              </a:rPr>
+              <a:t>Today we will begin Module 2 – Context-Free Grammars.</a:t>
+            </a:r>
+          </a:p>
+        </p:txBody>
+      </p:sp>
+    </p:spTree>
+    <p:extLst>
+      <p:ext uri="{BB962C8B-B14F-4D97-AF65-F5344CB8AC3E}">
+        <p14:creationId xmlns:p14="http://schemas.microsoft.com/office/powerpoint/2010/main" val="714086908"/>
+      </p:ext>
+    </p:extLst>
+  </p:cSld>
+  <p:clrMapOvr>
+    <a:masterClrMapping/>
+  </p:clrMapOvr>
+</p:sld>
+</file>
+
+<file path=ppt/slides/slide12.xml><?xml version="1.0" encoding="utf-8"?>
+<p:sld xmlns:a="http://schemas.openxmlformats.org/drawingml/2006/main" xmlns:r="http://schemas.openxmlformats.org/officeDocument/2006/relationships" xmlns:p="http://schemas.openxmlformats.org/presentationml/2006/main">
+  <p:cSld>
+    <p:spTree>
+      <p:nvGrpSpPr>
         <p:cNvPr id="1" name=""/>
         <p:cNvGrpSpPr/>
         <p:nvPr/>
@@ -13533,7 +13821,7 @@
           <p:nvPr>
             <p:extLst>
               <p:ext uri="{D42A27DB-BD31-4B8C-83A1-F6EECF244321}">
-                <p14:modId xmlns:p14="http://schemas.microsoft.com/office/powerpoint/2010/main" val="1938593800"/>
+                <p14:modId xmlns:p14="http://schemas.microsoft.com/office/powerpoint/2010/main" val="1113002690"/>
               </p:ext>
             </p:extLst>
           </p:nvPr>
@@ -13629,7 +13917,7 @@
                       <a:pPr algn="ctr"/>
                       <a:r>
                         <a:rPr lang="en-US" i="0" dirty="0"/>
-                        <a:t>7</a:t>
+                        <a:t>8</a:t>
                       </a:r>
                     </a:p>
                   </a:txBody>
@@ -13643,7 +13931,7 @@
                       <a:pPr algn="ctr"/>
                       <a:r>
                         <a:rPr lang="en-US" i="0" dirty="0"/>
-                        <a:t>7</a:t>
+                        <a:t>8</a:t>
                       </a:r>
                     </a:p>
                   </a:txBody>
@@ -13688,14 +13976,14 @@
           <p:nvPr>
             <p:extLst>
               <p:ext uri="{D42A27DB-BD31-4B8C-83A1-F6EECF244321}">
-                <p14:modId xmlns:p14="http://schemas.microsoft.com/office/powerpoint/2010/main" val="2003054135"/>
+                <p14:modId xmlns:p14="http://schemas.microsoft.com/office/powerpoint/2010/main" val="3226694611"/>
               </p:ext>
             </p:extLst>
           </p:nvPr>
         </p:nvGraphicFramePr>
         <p:xfrm>
           <a:off x="2548834" y="3478771"/>
-          <a:ext cx="7255124" cy="2595880"/>
+          <a:ext cx="7255124" cy="2966720"/>
         </p:xfrm>
         <a:graphic>
           <a:graphicData uri="http://schemas.openxmlformats.org/drawingml/2006/table">
@@ -13805,7 +14093,7 @@
                       <a:pPr algn="ctr"/>
                       <a:r>
                         <a:rPr lang="en-US" dirty="0"/>
-                        <a:t>Mod 1 Written</a:t>
+                        <a:t>Mod 0 Written</a:t>
                       </a:r>
                     </a:p>
                   </a:txBody>
@@ -13869,7 +14157,7 @@
                       <a:pPr algn="ctr"/>
                       <a:r>
                         <a:rPr lang="en-US" dirty="0"/>
-                        <a:t>Mod 2 Written</a:t>
+                        <a:t>Mod 1 Written</a:t>
                       </a:r>
                     </a:p>
                   </a:txBody>
@@ -13883,7 +14171,7 @@
                       <a:pPr algn="ctr"/>
                       <a:r>
                         <a:rPr lang="en-US" dirty="0"/>
-                        <a:t>10</a:t>
+                        <a:t>78</a:t>
                       </a:r>
                     </a:p>
                   </a:txBody>
@@ -13933,7 +14221,7 @@
                       <a:pPr algn="ctr"/>
                       <a:r>
                         <a:rPr lang="en-US" dirty="0"/>
-                        <a:t>Mod 2: Programming</a:t>
+                        <a:t>Mod 1: Programming</a:t>
                       </a:r>
                     </a:p>
                   </a:txBody>
@@ -13997,7 +14285,7 @@
                       <a:pPr algn="ctr"/>
                       <a:r>
                         <a:rPr lang="en-US" dirty="0"/>
-                        <a:t>Mod 3 Written</a:t>
+                        <a:t>Mod 2 Written</a:t>
                       </a:r>
                     </a:p>
                   </a:txBody>
@@ -14061,7 +14349,7 @@
                       <a:pPr algn="ctr"/>
                       <a:r>
                         <a:rPr lang="en-US" dirty="0"/>
-                        <a:t>Mod 4 Written</a:t>
+                        <a:t>Mod 3 Written</a:t>
                       </a:r>
                     </a:p>
                   </a:txBody>
@@ -14113,6 +14401,69 @@
                 <a:extLst>
                   <a:ext uri="{0D108BD9-81ED-4DB2-BD59-A6C34878D82A}">
                     <a16:rowId xmlns:a16="http://schemas.microsoft.com/office/drawing/2014/main" val="999239085"/>
+                  </a:ext>
+                </a:extLst>
+              </a:tr>
+              <a:tr h="370840">
+                <a:tc>
+                  <a:txBody>
+                    <a:bodyPr/>
+                    <a:lstStyle/>
+                    <a:p>
+                      <a:pPr algn="ctr"/>
+                      <a:r>
+                        <a:rPr lang="en-US" dirty="0"/>
+                        <a:t>Mod 4 Written</a:t>
+                      </a:r>
+                    </a:p>
+                  </a:txBody>
+                  <a:tcPr/>
+                </a:tc>
+                <a:tc>
+                  <a:txBody>
+                    <a:bodyPr/>
+                    <a:lstStyle/>
+                    <a:p>
+                      <a:pPr algn="ctr"/>
+                      <a:r>
+                        <a:rPr lang="en-US" dirty="0"/>
+                        <a:t>-</a:t>
+                      </a:r>
+                    </a:p>
+                  </a:txBody>
+                  <a:tcPr/>
+                </a:tc>
+                <a:tc>
+                  <a:txBody>
+                    <a:bodyPr/>
+                    <a:lstStyle/>
+                    <a:p>
+                      <a:pPr algn="ctr"/>
+                      <a:r>
+                        <a:rPr lang="en-US" dirty="0"/>
+                        <a:t>-</a:t>
+                      </a:r>
+                    </a:p>
+                  </a:txBody>
+                  <a:tcPr/>
+                </a:tc>
+                <a:tc>
+                  <a:txBody>
+                    <a:bodyPr/>
+                    <a:lstStyle/>
+                    <a:p>
+                      <a:pPr algn="ctr"/>
+                      <a:r>
+                        <a:rPr lang="en-US" b="0" dirty="0"/>
+                        <a:t>N/A</a:t>
+                      </a:r>
+                    </a:p>
+                  </a:txBody>
+                  <a:tcPr/>
+                </a:tc>
+                <a:extLst>
+                  <a:ext uri="{0D108BD9-81ED-4DB2-BD59-A6C34878D82A}">
+                    <a16:rowId xmlns:a16="http://schemas.microsoft.com/office/drawing/2014/main" val="1784064154"/>
                   </a:ext>
                 </a:extLst>
               </a:tr>
@@ -14813,7 +15164,7 @@
           <p:nvPr>
             <p:extLst>
               <p:ext uri="{D42A27DB-BD31-4B8C-83A1-F6EECF244321}">
-                <p14:modId xmlns:p14="http://schemas.microsoft.com/office/powerpoint/2010/main" val="1262790351"/>
+                <p14:modId xmlns:p14="http://schemas.microsoft.com/office/powerpoint/2010/main" val="105119426"/>
               </p:ext>
             </p:extLst>
           </p:nvPr>
@@ -14909,7 +15260,7 @@
                       <a:pPr algn="ctr"/>
                       <a:r>
                         <a:rPr lang="en-US" i="0" dirty="0"/>
-                        <a:t>7</a:t>
+                        <a:t>8</a:t>
                       </a:r>
                     </a:p>
                   </a:txBody>
@@ -14923,7 +15274,7 @@
                       <a:pPr algn="ctr"/>
                       <a:r>
                         <a:rPr lang="en-US" i="0" dirty="0"/>
-                        <a:t>7</a:t>
+                        <a:t>8</a:t>
                       </a:r>
                     </a:p>
                   </a:txBody>
@@ -17452,6 +17803,18 @@
 </file>
 
 <file path=ppt/tags/tag24.xml><?xml version="1.0" encoding="utf-8"?>
+<p:tagLst xmlns:a="http://schemas.openxmlformats.org/drawingml/2006/main" xmlns:r="http://schemas.openxmlformats.org/officeDocument/2006/relationships" xmlns:p="http://schemas.openxmlformats.org/presentationml/2006/main">
+  <p:tag name="_INSTRUCTOR VIEW19C14C36-AC8E-43BC-9DB6-C2AAF774C7DC|PANE__TAG" val="_"/>
+</p:tagLst>
+</file>
+
+<file path=ppt/tags/tag25.xml><?xml version="1.0" encoding="utf-8"?>
+<p:tagLst xmlns:a="http://schemas.openxmlformats.org/drawingml/2006/main" xmlns:r="http://schemas.openxmlformats.org/officeDocument/2006/relationships" xmlns:p="http://schemas.openxmlformats.org/presentationml/2006/main">
+  <p:tag name="_INSTRUCTOR VIEW19C14C36-AC8E-43BC-9DB6-C2AAF774C7DC|PANE__TAG" val="_"/>
+</p:tagLst>
+</file>
+
+<file path=ppt/tags/tag26.xml><?xml version="1.0" encoding="utf-8"?>
 <p:tagLst xmlns:a="http://schemas.openxmlformats.org/drawingml/2006/main" xmlns:r="http://schemas.openxmlformats.org/officeDocument/2006/relationships" xmlns:p="http://schemas.openxmlformats.org/presentationml/2006/main">
   <p:tag name="_INSTRUCTOR VIEW19C14C36-AC8E-43BC-9DB6-C2AAF774C7DC|PANE__TAG" val="_"/>
 </p:tagLst>

</xml_diff>

<commit_message>
changes to syllabus and announcements
</commit_message>
<xml_diff>
--- a/slides/00-DailyAnnouncements.pptx
+++ b/slides/00-DailyAnnouncements.pptx
@@ -5,7 +5,7 @@
     <p:sldMasterId id="2147484006" r:id="rId1"/>
   </p:sldMasterIdLst>
   <p:notesMasterIdLst>
-    <p:notesMasterId r:id="rId15"/>
+    <p:notesMasterId r:id="rId16"/>
   </p:notesMasterIdLst>
   <p:sldIdLst>
     <p:sldId id="256" r:id="rId2"/>
@@ -20,7 +20,8 @@
     <p:sldId id="523" r:id="rId11"/>
     <p:sldId id="524" r:id="rId12"/>
     <p:sldId id="525" r:id="rId13"/>
-    <p:sldId id="515" r:id="rId14"/>
+    <p:sldId id="526" r:id="rId14"/>
+    <p:sldId id="515" r:id="rId15"/>
   </p:sldIdLst>
   <p:sldSz cx="12192000" cy="6858000"/>
   <p:notesSz cx="6858000" cy="9144000"/>
@@ -209,7 +210,7 @@
           <a:p>
             <a:fld id="{C5B45307-6ED4-B142-BD64-10F739779302}" type="datetimeFigureOut">
               <a:rPr lang="en-US" smtClean="0"/>
-              <a:t>9/24/26</a:t>
+              <a:t>9/28/26</a:t>
             </a:fld>
             <a:endParaRPr lang="en-US"/>
           </a:p>
@@ -617,7 +618,7 @@
           <a:noFill/>
           <a:extLst>
             <a:ext uri="{909E8E84-426E-40dd-AFC4-6F175D3DCCD1}">
-              <a14:hiddenFill xmlns="" xmlns:a14="http://schemas.microsoft.com/office/drawing/2010/main">
+              <a14:hiddenFill xmlns:a14="http://schemas.microsoft.com/office/drawing/2010/main" xmlns="">
                 <a:solidFill>
                   <a:srgbClr val="FFFFFF"/>
                 </a:solidFill>
@@ -676,7 +677,7 @@
             </a:ln>
             <a:extLst>
               <a:ext uri="{91240B29-F687-4f45-9708-019B960494DF}">
-                <a14:hiddenLine xmlns="" xmlns:a14="http://schemas.microsoft.com/office/drawing/2010/main" w="9525">
+                <a14:hiddenLine xmlns:a14="http://schemas.microsoft.com/office/drawing/2010/main" xmlns="" w="9525">
                   <a:solidFill>
                     <a:srgbClr val="000000"/>
                   </a:solidFill>
@@ -766,7 +767,7 @@
             </a:ln>
             <a:extLst>
               <a:ext uri="{91240B29-F687-4f45-9708-019B960494DF}">
-                <a14:hiddenLine xmlns="" xmlns:a14="http://schemas.microsoft.com/office/drawing/2010/main" w="9525">
+                <a14:hiddenLine xmlns:a14="http://schemas.microsoft.com/office/drawing/2010/main" xmlns="" w="9525">
                   <a:solidFill>
                     <a:srgbClr val="000000"/>
                   </a:solidFill>
@@ -856,7 +857,7 @@
             </a:ln>
             <a:extLst>
               <a:ext uri="{91240B29-F687-4f45-9708-019B960494DF}">
-                <a14:hiddenLine xmlns="" xmlns:a14="http://schemas.microsoft.com/office/drawing/2010/main" w="9525">
+                <a14:hiddenLine xmlns:a14="http://schemas.microsoft.com/office/drawing/2010/main" xmlns="" w="9525">
                   <a:solidFill>
                     <a:srgbClr val="000000"/>
                   </a:solidFill>
@@ -890,7 +891,7 @@
             </a:ln>
             <a:extLst>
               <a:ext uri="{91240B29-F687-4f45-9708-019B960494DF}">
-                <a14:hiddenLine xmlns="" xmlns:a14="http://schemas.microsoft.com/office/drawing/2010/main" w="9525">
+                <a14:hiddenLine xmlns:a14="http://schemas.microsoft.com/office/drawing/2010/main" xmlns="" w="9525">
                   <a:solidFill>
                     <a:srgbClr val="000000"/>
                   </a:solidFill>
@@ -980,7 +981,7 @@
             </a:ln>
             <a:extLst>
               <a:ext uri="{91240B29-F687-4f45-9708-019B960494DF}">
-                <a14:hiddenLine xmlns="" xmlns:a14="http://schemas.microsoft.com/office/drawing/2010/main" w="9525">
+                <a14:hiddenLine xmlns:a14="http://schemas.microsoft.com/office/drawing/2010/main" xmlns="" w="9525">
                   <a:solidFill>
                     <a:srgbClr val="000000"/>
                   </a:solidFill>
@@ -1042,7 +1043,7 @@
             </a:ln>
             <a:extLst>
               <a:ext uri="{91240B29-F687-4f45-9708-019B960494DF}">
-                <a14:hiddenLine xmlns="" xmlns:a14="http://schemas.microsoft.com/office/drawing/2010/main" w="9525">
+                <a14:hiddenLine xmlns:a14="http://schemas.microsoft.com/office/drawing/2010/main" xmlns="" w="9525">
                   <a:solidFill>
                     <a:srgbClr val="000000"/>
                   </a:solidFill>
@@ -1104,7 +1105,7 @@
             </a:ln>
             <a:extLst>
               <a:ext uri="{91240B29-F687-4f45-9708-019B960494DF}">
-                <a14:hiddenLine xmlns="" xmlns:a14="http://schemas.microsoft.com/office/drawing/2010/main" w="9525">
+                <a14:hiddenLine xmlns:a14="http://schemas.microsoft.com/office/drawing/2010/main" xmlns="" w="9525">
                   <a:solidFill>
                     <a:srgbClr val="000000"/>
                   </a:solidFill>
@@ -1194,7 +1195,7 @@
             </a:ln>
             <a:extLst>
               <a:ext uri="{91240B29-F687-4f45-9708-019B960494DF}">
-                <a14:hiddenLine xmlns="" xmlns:a14="http://schemas.microsoft.com/office/drawing/2010/main" w="9525">
+                <a14:hiddenLine xmlns:a14="http://schemas.microsoft.com/office/drawing/2010/main" xmlns="" w="9525">
                   <a:solidFill>
                     <a:srgbClr val="000000"/>
                   </a:solidFill>
@@ -1256,7 +1257,7 @@
             </a:ln>
             <a:extLst>
               <a:ext uri="{91240B29-F687-4f45-9708-019B960494DF}">
-                <a14:hiddenLine xmlns="" xmlns:a14="http://schemas.microsoft.com/office/drawing/2010/main" w="9525">
+                <a14:hiddenLine xmlns:a14="http://schemas.microsoft.com/office/drawing/2010/main" xmlns="" w="9525">
                   <a:solidFill>
                     <a:srgbClr val="000000"/>
                   </a:solidFill>
@@ -1318,7 +1319,7 @@
             </a:ln>
             <a:extLst>
               <a:ext uri="{91240B29-F687-4f45-9708-019B960494DF}">
-                <a14:hiddenLine xmlns="" xmlns:a14="http://schemas.microsoft.com/office/drawing/2010/main" w="9525">
+                <a14:hiddenLine xmlns:a14="http://schemas.microsoft.com/office/drawing/2010/main" xmlns="" w="9525">
                   <a:solidFill>
                     <a:srgbClr val="000000"/>
                   </a:solidFill>
@@ -1408,7 +1409,7 @@
             </a:ln>
             <a:extLst>
               <a:ext uri="{91240B29-F687-4f45-9708-019B960494DF}">
-                <a14:hiddenLine xmlns="" xmlns:a14="http://schemas.microsoft.com/office/drawing/2010/main" w="9525">
+                <a14:hiddenLine xmlns:a14="http://schemas.microsoft.com/office/drawing/2010/main" xmlns="" w="9525">
                   <a:solidFill>
                     <a:srgbClr val="000000"/>
                   </a:solidFill>
@@ -1498,7 +1499,7 @@
             </a:ln>
             <a:extLst>
               <a:ext uri="{91240B29-F687-4f45-9708-019B960494DF}">
-                <a14:hiddenLine xmlns="" xmlns:a14="http://schemas.microsoft.com/office/drawing/2010/main" w="9525">
+                <a14:hiddenLine xmlns:a14="http://schemas.microsoft.com/office/drawing/2010/main" xmlns="" w="9525">
                   <a:solidFill>
                     <a:srgbClr val="000000"/>
                   </a:solidFill>
@@ -1560,7 +1561,7 @@
             </a:ln>
             <a:extLst>
               <a:ext uri="{91240B29-F687-4f45-9708-019B960494DF}">
-                <a14:hiddenLine xmlns="" xmlns:a14="http://schemas.microsoft.com/office/drawing/2010/main" w="9525">
+                <a14:hiddenLine xmlns:a14="http://schemas.microsoft.com/office/drawing/2010/main" xmlns="" w="9525">
                   <a:solidFill>
                     <a:srgbClr val="000000"/>
                   </a:solidFill>
@@ -1670,7 +1671,7 @@
             </a:ln>
             <a:extLst>
               <a:ext uri="{91240B29-F687-4f45-9708-019B960494DF}">
-                <a14:hiddenLine xmlns="" xmlns:a14="http://schemas.microsoft.com/office/drawing/2010/main" w="9525">
+                <a14:hiddenLine xmlns:a14="http://schemas.microsoft.com/office/drawing/2010/main" xmlns="" w="9525">
                   <a:solidFill>
                     <a:srgbClr val="000000"/>
                   </a:solidFill>
@@ -1732,7 +1733,7 @@
             </a:ln>
             <a:extLst>
               <a:ext uri="{91240B29-F687-4f45-9708-019B960494DF}">
-                <a14:hiddenLine xmlns="" xmlns:a14="http://schemas.microsoft.com/office/drawing/2010/main" w="9525">
+                <a14:hiddenLine xmlns:a14="http://schemas.microsoft.com/office/drawing/2010/main" xmlns="" w="9525">
                   <a:solidFill>
                     <a:srgbClr val="000000"/>
                   </a:solidFill>
@@ -1822,7 +1823,7 @@
             </a:ln>
             <a:extLst>
               <a:ext uri="{91240B29-F687-4f45-9708-019B960494DF}">
-                <a14:hiddenLine xmlns="" xmlns:a14="http://schemas.microsoft.com/office/drawing/2010/main" w="9525">
+                <a14:hiddenLine xmlns:a14="http://schemas.microsoft.com/office/drawing/2010/main" xmlns="" w="9525">
                   <a:solidFill>
                     <a:srgbClr val="000000"/>
                   </a:solidFill>
@@ -1912,7 +1913,7 @@
             </a:ln>
             <a:extLst>
               <a:ext uri="{91240B29-F687-4f45-9708-019B960494DF}">
-                <a14:hiddenLine xmlns="" xmlns:a14="http://schemas.microsoft.com/office/drawing/2010/main" w="9525">
+                <a14:hiddenLine xmlns:a14="http://schemas.microsoft.com/office/drawing/2010/main" xmlns="" w="9525">
                   <a:solidFill>
                     <a:srgbClr val="000000"/>
                   </a:solidFill>
@@ -1974,7 +1975,7 @@
             </a:ln>
             <a:extLst>
               <a:ext uri="{91240B29-F687-4f45-9708-019B960494DF}">
-                <a14:hiddenLine xmlns="" xmlns:a14="http://schemas.microsoft.com/office/drawing/2010/main" w="9525">
+                <a14:hiddenLine xmlns:a14="http://schemas.microsoft.com/office/drawing/2010/main" xmlns="" w="9525">
                   <a:solidFill>
                     <a:srgbClr val="000000"/>
                   </a:solidFill>
@@ -2064,7 +2065,7 @@
             </a:ln>
             <a:extLst>
               <a:ext uri="{91240B29-F687-4f45-9708-019B960494DF}">
-                <a14:hiddenLine xmlns="" xmlns:a14="http://schemas.microsoft.com/office/drawing/2010/main" w="9525">
+                <a14:hiddenLine xmlns:a14="http://schemas.microsoft.com/office/drawing/2010/main" xmlns="" w="9525">
                   <a:solidFill>
                     <a:srgbClr val="000000"/>
                   </a:solidFill>
@@ -2154,7 +2155,7 @@
             </a:ln>
             <a:extLst>
               <a:ext uri="{91240B29-F687-4f45-9708-019B960494DF}">
-                <a14:hiddenLine xmlns="" xmlns:a14="http://schemas.microsoft.com/office/drawing/2010/main" w="9525">
+                <a14:hiddenLine xmlns:a14="http://schemas.microsoft.com/office/drawing/2010/main" xmlns="" w="9525">
                   <a:solidFill>
                     <a:srgbClr val="000000"/>
                   </a:solidFill>
@@ -2210,7 +2211,7 @@
             </a:ln>
             <a:extLst>
               <a:ext uri="{91240B29-F687-4f45-9708-019B960494DF}">
-                <a14:hiddenLine xmlns="" xmlns:a14="http://schemas.microsoft.com/office/drawing/2010/main" w="9525">
+                <a14:hiddenLine xmlns:a14="http://schemas.microsoft.com/office/drawing/2010/main" xmlns="" w="9525">
                   <a:solidFill>
                     <a:srgbClr val="000000"/>
                   </a:solidFill>
@@ -2300,7 +2301,7 @@
             </a:ln>
             <a:extLst>
               <a:ext uri="{91240B29-F687-4f45-9708-019B960494DF}">
-                <a14:hiddenLine xmlns="" xmlns:a14="http://schemas.microsoft.com/office/drawing/2010/main" w="9525">
+                <a14:hiddenLine xmlns:a14="http://schemas.microsoft.com/office/drawing/2010/main" xmlns="" w="9525">
                   <a:solidFill>
                     <a:srgbClr val="000000"/>
                   </a:solidFill>
@@ -2356,7 +2357,7 @@
             </a:ln>
             <a:extLst>
               <a:ext uri="{91240B29-F687-4f45-9708-019B960494DF}">
-                <a14:hiddenLine xmlns="" xmlns:a14="http://schemas.microsoft.com/office/drawing/2010/main" w="9525">
+                <a14:hiddenLine xmlns:a14="http://schemas.microsoft.com/office/drawing/2010/main" xmlns="" w="9525">
                   <a:solidFill>
                     <a:srgbClr val="000000"/>
                   </a:solidFill>
@@ -2446,7 +2447,7 @@
             </a:ln>
             <a:extLst>
               <a:ext uri="{91240B29-F687-4f45-9708-019B960494DF}">
-                <a14:hiddenLine xmlns="" xmlns:a14="http://schemas.microsoft.com/office/drawing/2010/main" w="9525">
+                <a14:hiddenLine xmlns:a14="http://schemas.microsoft.com/office/drawing/2010/main" xmlns="" w="9525">
                   <a:solidFill>
                     <a:srgbClr val="000000"/>
                   </a:solidFill>
@@ -2514,7 +2515,7 @@
             </a:ln>
             <a:extLst>
               <a:ext uri="{91240B29-F687-4f45-9708-019B960494DF}">
-                <a14:hiddenLine xmlns="" xmlns:a14="http://schemas.microsoft.com/office/drawing/2010/main" w="9525">
+                <a14:hiddenLine xmlns:a14="http://schemas.microsoft.com/office/drawing/2010/main" xmlns="" w="9525">
                   <a:solidFill>
                     <a:srgbClr val="000000"/>
                   </a:solidFill>
@@ -2604,7 +2605,7 @@
             </a:ln>
             <a:extLst>
               <a:ext uri="{91240B29-F687-4f45-9708-019B960494DF}">
-                <a14:hiddenLine xmlns="" xmlns:a14="http://schemas.microsoft.com/office/drawing/2010/main" w="9525">
+                <a14:hiddenLine xmlns:a14="http://schemas.microsoft.com/office/drawing/2010/main" xmlns="" w="9525">
                   <a:solidFill>
                     <a:srgbClr val="000000"/>
                   </a:solidFill>
@@ -2672,7 +2673,7 @@
             </a:ln>
             <a:extLst>
               <a:ext uri="{91240B29-F687-4f45-9708-019B960494DF}">
-                <a14:hiddenLine xmlns="" xmlns:a14="http://schemas.microsoft.com/office/drawing/2010/main" w="9525">
+                <a14:hiddenLine xmlns:a14="http://schemas.microsoft.com/office/drawing/2010/main" xmlns="" w="9525">
                   <a:solidFill>
                     <a:srgbClr val="000000"/>
                   </a:solidFill>
@@ -2762,7 +2763,7 @@
             </a:ln>
             <a:extLst>
               <a:ext uri="{91240B29-F687-4f45-9708-019B960494DF}">
-                <a14:hiddenLine xmlns="" xmlns:a14="http://schemas.microsoft.com/office/drawing/2010/main" w="9525">
+                <a14:hiddenLine xmlns:a14="http://schemas.microsoft.com/office/drawing/2010/main" xmlns="" w="9525">
                   <a:solidFill>
                     <a:srgbClr val="000000"/>
                   </a:solidFill>
@@ -2796,7 +2797,7 @@
             </a:ln>
             <a:extLst>
               <a:ext uri="{91240B29-F687-4f45-9708-019B960494DF}">
-                <a14:hiddenLine xmlns="" xmlns:a14="http://schemas.microsoft.com/office/drawing/2010/main" w="9525">
+                <a14:hiddenLine xmlns:a14="http://schemas.microsoft.com/office/drawing/2010/main" xmlns="" w="9525">
                   <a:solidFill>
                     <a:srgbClr val="000000"/>
                   </a:solidFill>
@@ -2886,7 +2887,7 @@
             </a:ln>
             <a:extLst>
               <a:ext uri="{91240B29-F687-4f45-9708-019B960494DF}">
-                <a14:hiddenLine xmlns="" xmlns:a14="http://schemas.microsoft.com/office/drawing/2010/main" w="9525">
+                <a14:hiddenLine xmlns:a14="http://schemas.microsoft.com/office/drawing/2010/main" xmlns="" w="9525">
                   <a:solidFill>
                     <a:srgbClr val="000000"/>
                   </a:solidFill>
@@ -2948,7 +2949,7 @@
             </a:ln>
             <a:extLst>
               <a:ext uri="{91240B29-F687-4f45-9708-019B960494DF}">
-                <a14:hiddenLine xmlns="" xmlns:a14="http://schemas.microsoft.com/office/drawing/2010/main" w="9525">
+                <a14:hiddenLine xmlns:a14="http://schemas.microsoft.com/office/drawing/2010/main" xmlns="" w="9525">
                   <a:solidFill>
                     <a:srgbClr val="000000"/>
                   </a:solidFill>
@@ -3010,7 +3011,7 @@
             </a:ln>
             <a:extLst>
               <a:ext uri="{91240B29-F687-4f45-9708-019B960494DF}">
-                <a14:hiddenLine xmlns="" xmlns:a14="http://schemas.microsoft.com/office/drawing/2010/main" w="9525">
+                <a14:hiddenLine xmlns:a14="http://schemas.microsoft.com/office/drawing/2010/main" xmlns="" w="9525">
                   <a:solidFill>
                     <a:srgbClr val="000000"/>
                   </a:solidFill>
@@ -3100,7 +3101,7 @@
             </a:ln>
             <a:extLst>
               <a:ext uri="{91240B29-F687-4f45-9708-019B960494DF}">
-                <a14:hiddenLine xmlns="" xmlns:a14="http://schemas.microsoft.com/office/drawing/2010/main" w="9525">
+                <a14:hiddenLine xmlns:a14="http://schemas.microsoft.com/office/drawing/2010/main" xmlns="" w="9525">
                   <a:solidFill>
                     <a:srgbClr val="000000"/>
                   </a:solidFill>
@@ -3168,7 +3169,7 @@
             </a:ln>
             <a:extLst>
               <a:ext uri="{91240B29-F687-4f45-9708-019B960494DF}">
-                <a14:hiddenLine xmlns="" xmlns:a14="http://schemas.microsoft.com/office/drawing/2010/main" w="9525">
+                <a14:hiddenLine xmlns:a14="http://schemas.microsoft.com/office/drawing/2010/main" xmlns="" w="9525">
                   <a:solidFill>
                     <a:srgbClr val="000000"/>
                   </a:solidFill>
@@ -3230,7 +3231,7 @@
             </a:ln>
             <a:extLst>
               <a:ext uri="{91240B29-F687-4f45-9708-019B960494DF}">
-                <a14:hiddenLine xmlns="" xmlns:a14="http://schemas.microsoft.com/office/drawing/2010/main" w="9525">
+                <a14:hiddenLine xmlns:a14="http://schemas.microsoft.com/office/drawing/2010/main" xmlns="" w="9525">
                   <a:solidFill>
                     <a:srgbClr val="000000"/>
                   </a:solidFill>
@@ -3320,7 +3321,7 @@
             </a:ln>
             <a:extLst>
               <a:ext uri="{91240B29-F687-4f45-9708-019B960494DF}">
-                <a14:hiddenLine xmlns="" xmlns:a14="http://schemas.microsoft.com/office/drawing/2010/main" w="9525">
+                <a14:hiddenLine xmlns:a14="http://schemas.microsoft.com/office/drawing/2010/main" xmlns="" w="9525">
                   <a:solidFill>
                     <a:srgbClr val="000000"/>
                   </a:solidFill>
@@ -3382,7 +3383,7 @@
             </a:ln>
             <a:extLst>
               <a:ext uri="{91240B29-F687-4f45-9708-019B960494DF}">
-                <a14:hiddenLine xmlns="" xmlns:a14="http://schemas.microsoft.com/office/drawing/2010/main" w="9525">
+                <a14:hiddenLine xmlns:a14="http://schemas.microsoft.com/office/drawing/2010/main" xmlns="" w="9525">
                   <a:solidFill>
                     <a:srgbClr val="000000"/>
                   </a:solidFill>
@@ -3472,7 +3473,7 @@
             </a:ln>
             <a:extLst>
               <a:ext uri="{91240B29-F687-4f45-9708-019B960494DF}">
-                <a14:hiddenLine xmlns="" xmlns:a14="http://schemas.microsoft.com/office/drawing/2010/main" w="9525">
+                <a14:hiddenLine xmlns:a14="http://schemas.microsoft.com/office/drawing/2010/main" xmlns="" w="9525">
                   <a:solidFill>
                     <a:srgbClr val="000000"/>
                   </a:solidFill>
@@ -3534,7 +3535,7 @@
             </a:ln>
             <a:extLst>
               <a:ext uri="{91240B29-F687-4f45-9708-019B960494DF}">
-                <a14:hiddenLine xmlns="" xmlns:a14="http://schemas.microsoft.com/office/drawing/2010/main" w="9525">
+                <a14:hiddenLine xmlns:a14="http://schemas.microsoft.com/office/drawing/2010/main" xmlns="" w="9525">
                   <a:solidFill>
                     <a:srgbClr val="000000"/>
                   </a:solidFill>
@@ -3624,7 +3625,7 @@
             </a:ln>
             <a:extLst>
               <a:ext uri="{91240B29-F687-4f45-9708-019B960494DF}">
-                <a14:hiddenLine xmlns="" xmlns:a14="http://schemas.microsoft.com/office/drawing/2010/main" w="9525">
+                <a14:hiddenLine xmlns:a14="http://schemas.microsoft.com/office/drawing/2010/main" xmlns="" w="9525">
                   <a:solidFill>
                     <a:srgbClr val="000000"/>
                   </a:solidFill>
@@ -3658,7 +3659,7 @@
             </a:ln>
             <a:extLst>
               <a:ext uri="{91240B29-F687-4f45-9708-019B960494DF}">
-                <a14:hiddenLine xmlns="" xmlns:a14="http://schemas.microsoft.com/office/drawing/2010/main" w="9525">
+                <a14:hiddenLine xmlns:a14="http://schemas.microsoft.com/office/drawing/2010/main" xmlns="" w="9525">
                   <a:solidFill>
                     <a:srgbClr val="000000"/>
                   </a:solidFill>
@@ -3723,7 +3724,7 @@
             </a:ln>
             <a:extLst>
               <a:ext uri="{91240B29-F687-4f45-9708-019B960494DF}">
-                <a14:hiddenLine xmlns="" xmlns:a14="http://schemas.microsoft.com/office/drawing/2010/main" w="9525">
+                <a14:hiddenLine xmlns:a14="http://schemas.microsoft.com/office/drawing/2010/main" xmlns="" w="9525">
                   <a:solidFill>
                     <a:srgbClr val="000000"/>
                   </a:solidFill>
@@ -3813,7 +3814,7 @@
             </a:ln>
             <a:extLst>
               <a:ext uri="{91240B29-F687-4f45-9708-019B960494DF}">
-                <a14:hiddenLine xmlns="" xmlns:a14="http://schemas.microsoft.com/office/drawing/2010/main" w="9525">
+                <a14:hiddenLine xmlns:a14="http://schemas.microsoft.com/office/drawing/2010/main" xmlns="" w="9525">
                   <a:solidFill>
                     <a:srgbClr val="000000"/>
                   </a:solidFill>
@@ -3875,7 +3876,7 @@
             </a:ln>
             <a:extLst>
               <a:ext uri="{91240B29-F687-4f45-9708-019B960494DF}">
-                <a14:hiddenLine xmlns="" xmlns:a14="http://schemas.microsoft.com/office/drawing/2010/main" w="9525">
+                <a14:hiddenLine xmlns:a14="http://schemas.microsoft.com/office/drawing/2010/main" xmlns="" w="9525">
                   <a:solidFill>
                     <a:srgbClr val="000000"/>
                   </a:solidFill>
@@ -3965,7 +3966,7 @@
             </a:ln>
             <a:extLst>
               <a:ext uri="{91240B29-F687-4f45-9708-019B960494DF}">
-                <a14:hiddenLine xmlns="" xmlns:a14="http://schemas.microsoft.com/office/drawing/2010/main" w="9525">
+                <a14:hiddenLine xmlns:a14="http://schemas.microsoft.com/office/drawing/2010/main" xmlns="" w="9525">
                   <a:solidFill>
                     <a:srgbClr val="000000"/>
                   </a:solidFill>
@@ -4055,7 +4056,7 @@
             </a:ln>
             <a:extLst>
               <a:ext uri="{91240B29-F687-4f45-9708-019B960494DF}">
-                <a14:hiddenLine xmlns="" xmlns:a14="http://schemas.microsoft.com/office/drawing/2010/main" w="9525">
+                <a14:hiddenLine xmlns:a14="http://schemas.microsoft.com/office/drawing/2010/main" xmlns="" w="9525">
                   <a:solidFill>
                     <a:srgbClr val="000000"/>
                   </a:solidFill>
@@ -4120,7 +4121,7 @@
             </a:ln>
             <a:extLst>
               <a:ext uri="{91240B29-F687-4f45-9708-019B960494DF}">
-                <a14:hiddenLine xmlns="" xmlns:a14="http://schemas.microsoft.com/office/drawing/2010/main" w="9525">
+                <a14:hiddenLine xmlns:a14="http://schemas.microsoft.com/office/drawing/2010/main" xmlns="" w="9525">
                   <a:solidFill>
                     <a:srgbClr val="000000"/>
                   </a:solidFill>
@@ -4182,7 +4183,7 @@
             </a:ln>
             <a:extLst>
               <a:ext uri="{91240B29-F687-4f45-9708-019B960494DF}">
-                <a14:hiddenLine xmlns="" xmlns:a14="http://schemas.microsoft.com/office/drawing/2010/main" w="9525">
+                <a14:hiddenLine xmlns:a14="http://schemas.microsoft.com/office/drawing/2010/main" xmlns="" w="9525">
                   <a:solidFill>
                     <a:srgbClr val="000000"/>
                   </a:solidFill>
@@ -4272,7 +4273,7 @@
             </a:ln>
             <a:extLst>
               <a:ext uri="{91240B29-F687-4f45-9708-019B960494DF}">
-                <a14:hiddenLine xmlns="" xmlns:a14="http://schemas.microsoft.com/office/drawing/2010/main" w="9525">
+                <a14:hiddenLine xmlns:a14="http://schemas.microsoft.com/office/drawing/2010/main" xmlns="" w="9525">
                   <a:solidFill>
                     <a:srgbClr val="000000"/>
                   </a:solidFill>
@@ -4362,7 +4363,7 @@
             </a:ln>
             <a:extLst>
               <a:ext uri="{91240B29-F687-4f45-9708-019B960494DF}">
-                <a14:hiddenLine xmlns="" xmlns:a14="http://schemas.microsoft.com/office/drawing/2010/main" w="9525">
+                <a14:hiddenLine xmlns:a14="http://schemas.microsoft.com/office/drawing/2010/main" xmlns="" w="9525">
                   <a:solidFill>
                     <a:srgbClr val="000000"/>
                   </a:solidFill>
@@ -4424,7 +4425,7 @@
             </a:ln>
             <a:extLst>
               <a:ext uri="{91240B29-F687-4f45-9708-019B960494DF}">
-                <a14:hiddenLine xmlns="" xmlns:a14="http://schemas.microsoft.com/office/drawing/2010/main" w="9525">
+                <a14:hiddenLine xmlns:a14="http://schemas.microsoft.com/office/drawing/2010/main" xmlns="" w="9525">
                   <a:solidFill>
                     <a:srgbClr val="000000"/>
                   </a:solidFill>
@@ -4544,7 +4545,7 @@
             </a:ln>
             <a:extLst>
               <a:ext uri="{91240B29-F687-4f45-9708-019B960494DF}">
-                <a14:hiddenLine xmlns="" xmlns:a14="http://schemas.microsoft.com/office/drawing/2010/main" w="9525">
+                <a14:hiddenLine xmlns:a14="http://schemas.microsoft.com/office/drawing/2010/main" xmlns="" w="9525">
                   <a:solidFill>
                     <a:srgbClr val="000000"/>
                   </a:solidFill>
@@ -4612,7 +4613,7 @@
             </a:ln>
             <a:extLst>
               <a:ext uri="{91240B29-F687-4f45-9708-019B960494DF}">
-                <a14:hiddenLine xmlns="" xmlns:a14="http://schemas.microsoft.com/office/drawing/2010/main" w="9525">
+                <a14:hiddenLine xmlns:a14="http://schemas.microsoft.com/office/drawing/2010/main" xmlns="" w="9525">
                   <a:solidFill>
                     <a:srgbClr val="000000"/>
                   </a:solidFill>
@@ -4702,7 +4703,7 @@
             </a:ln>
             <a:extLst>
               <a:ext uri="{91240B29-F687-4f45-9708-019B960494DF}">
-                <a14:hiddenLine xmlns="" xmlns:a14="http://schemas.microsoft.com/office/drawing/2010/main" w="9525">
+                <a14:hiddenLine xmlns:a14="http://schemas.microsoft.com/office/drawing/2010/main" xmlns="" w="9525">
                   <a:solidFill>
                     <a:srgbClr val="000000"/>
                   </a:solidFill>
@@ -4842,7 +4843,7 @@
           <a:p>
             <a:fld id="{4313F670-7F9A-774D-B73D-573401E44297}" type="datetime1">
               <a:rPr lang="en-US" smtClean="0"/>
-              <a:t>9/24/26</a:t>
+              <a:t>9/28/26</a:t>
             </a:fld>
             <a:endParaRPr lang="en-US"/>
           </a:p>
@@ -5109,7 +5110,7 @@
           <a:p>
             <a:fld id="{446F9669-A8A7-2D40-9D01-B35FC337AA30}" type="datetime1">
               <a:rPr lang="en-US" smtClean="0"/>
-              <a:t>9/24/26</a:t>
+              <a:t>9/28/26</a:t>
             </a:fld>
             <a:endParaRPr lang="en-US"/>
           </a:p>
@@ -5305,7 +5306,7 @@
           <a:p>
             <a:fld id="{FA76CF18-F41B-6B48-B3E5-599E9795C2C3}" type="datetime1">
               <a:rPr lang="en-US" smtClean="0"/>
-              <a:t>9/24/26</a:t>
+              <a:t>9/28/26</a:t>
             </a:fld>
             <a:endParaRPr lang="en-US"/>
           </a:p>
@@ -5568,7 +5569,7 @@
           <a:p>
             <a:fld id="{B9654854-6457-164F-A077-6B3035079B82}" type="datetime1">
               <a:rPr lang="en-US" smtClean="0"/>
-              <a:t>9/24/26</a:t>
+              <a:t>9/28/26</a:t>
             </a:fld>
             <a:endParaRPr lang="en-US"/>
           </a:p>
@@ -6002,7 +6003,7 @@
           <a:p>
             <a:fld id="{CE3DBFD7-E611-8C40-AC73-0C29FF63F0CD}" type="datetime1">
               <a:rPr lang="en-US" smtClean="0"/>
-              <a:t>9/24/26</a:t>
+              <a:t>9/28/26</a:t>
             </a:fld>
             <a:endParaRPr lang="en-US"/>
           </a:p>
@@ -6548,7 +6549,7 @@
           <a:p>
             <a:fld id="{C8B63B06-0493-2840-9F37-30C9412BBF17}" type="datetime1">
               <a:rPr lang="en-US" smtClean="0"/>
-              <a:t>9/24/26</a:t>
+              <a:t>9/28/26</a:t>
             </a:fld>
             <a:endParaRPr lang="en-US"/>
           </a:p>
@@ -7268,7 +7269,7 @@
           <a:p>
             <a:fld id="{72B5C0FA-8C46-E84D-B6D7-B673F2CA0A0E}" type="datetime1">
               <a:rPr lang="en-US" smtClean="0"/>
-              <a:t>9/24/26</a:t>
+              <a:t>9/28/26</a:t>
             </a:fld>
             <a:endParaRPr lang="en-US"/>
           </a:p>
@@ -7438,7 +7439,7 @@
           <a:p>
             <a:fld id="{60B9CDE1-97B4-BF46-B69C-B86855B18820}" type="datetime1">
               <a:rPr lang="en-US" smtClean="0"/>
-              <a:t>9/24/26</a:t>
+              <a:t>9/28/26</a:t>
             </a:fld>
             <a:endParaRPr lang="en-US"/>
           </a:p>
@@ -7618,7 +7619,7 @@
           <a:p>
             <a:fld id="{BE51D3A4-F9E5-FD49-AA87-B395F50451DC}" type="datetime1">
               <a:rPr lang="en-US" smtClean="0"/>
-              <a:t>9/24/26</a:t>
+              <a:t>9/28/26</a:t>
             </a:fld>
             <a:endParaRPr lang="en-US"/>
           </a:p>
@@ -7788,7 +7789,7 @@
           <a:p>
             <a:fld id="{880DFB37-B0AE-9449-85EC-14F9C83B6084}" type="datetime1">
               <a:rPr lang="en-US" smtClean="0"/>
-              <a:t>9/24/26</a:t>
+              <a:t>9/28/26</a:t>
             </a:fld>
             <a:endParaRPr lang="en-US"/>
           </a:p>
@@ -8038,7 +8039,7 @@
           <a:p>
             <a:fld id="{C939124A-616E-6944-A21A-1839F5DBE7BB}" type="datetime1">
               <a:rPr lang="en-US" smtClean="0"/>
-              <a:t>9/24/26</a:t>
+              <a:t>9/28/26</a:t>
             </a:fld>
             <a:endParaRPr lang="en-US"/>
           </a:p>
@@ -8270,7 +8271,7 @@
           <a:p>
             <a:fld id="{C6E9A026-D48C-FD43-8676-CD625DD5D84B}" type="datetime1">
               <a:rPr lang="en-US" smtClean="0"/>
-              <a:t>9/24/26</a:t>
+              <a:t>9/28/26</a:t>
             </a:fld>
             <a:endParaRPr lang="en-US"/>
           </a:p>
@@ -8656,7 +8657,7 @@
           <a:p>
             <a:fld id="{EA35111E-23A3-1440-99A3-C4C665908E3D}" type="datetime1">
               <a:rPr lang="en-US" smtClean="0"/>
-              <a:t>9/24/26</a:t>
+              <a:t>9/28/26</a:t>
             </a:fld>
             <a:endParaRPr lang="en-US"/>
           </a:p>
@@ -8779,7 +8780,7 @@
           <a:p>
             <a:fld id="{249983B9-88EF-D74B-BA6D-6A3BF17C2B38}" type="datetime1">
               <a:rPr lang="en-US" smtClean="0"/>
-              <a:t>9/24/26</a:t>
+              <a:t>9/28/26</a:t>
             </a:fld>
             <a:endParaRPr lang="en-US"/>
           </a:p>
@@ -8874,7 +8875,7 @@
           <a:p>
             <a:fld id="{E2A00AEF-B4EC-084A-8DB8-A225C7981CBB}" type="datetime1">
               <a:rPr lang="en-US" smtClean="0"/>
-              <a:t>9/24/26</a:t>
+              <a:t>9/28/26</a:t>
             </a:fld>
             <a:endParaRPr lang="en-US"/>
           </a:p>
@@ -9123,7 +9124,7 @@
           <a:p>
             <a:fld id="{97860299-21CD-A94A-A7B0-44E787F8D42C}" type="datetime1">
               <a:rPr lang="en-US" smtClean="0"/>
-              <a:t>9/24/26</a:t>
+              <a:t>9/28/26</a:t>
             </a:fld>
             <a:endParaRPr lang="en-US"/>
           </a:p>
@@ -9408,7 +9409,7 @@
           <a:p>
             <a:fld id="{3DFD19CF-4E62-D246-BA61-7B528271315F}" type="datetime1">
               <a:rPr lang="en-US" smtClean="0"/>
-              <a:t>9/24/26</a:t>
+              <a:t>9/28/26</a:t>
             </a:fld>
             <a:endParaRPr lang="en-US"/>
           </a:p>
@@ -9531,7 +9532,7 @@
           <a:noFill/>
           <a:extLst>
             <a:ext uri="{909E8E84-426E-40dd-AFC4-6F175D3DCCD1}">
-              <a14:hiddenFill xmlns="" xmlns:a14="http://schemas.microsoft.com/office/drawing/2010/main">
+              <a14:hiddenFill xmlns:a14="http://schemas.microsoft.com/office/drawing/2010/main" xmlns="">
                 <a:solidFill>
                   <a:srgbClr val="FFFFFF"/>
                 </a:solidFill>
@@ -9605,7 +9606,7 @@
               </a:ln>
               <a:extLst>
                 <a:ext uri="{91240B29-F687-4f45-9708-019B960494DF}">
-                  <a14:hiddenLine xmlns="" xmlns:a14="http://schemas.microsoft.com/office/drawing/2010/main" w="9525">
+                  <a14:hiddenLine xmlns:a14="http://schemas.microsoft.com/office/drawing/2010/main" xmlns="" w="9525">
                     <a:solidFill>
                       <a:srgbClr val="000000"/>
                     </a:solidFill>
@@ -9695,7 +9696,7 @@
               </a:ln>
               <a:extLst>
                 <a:ext uri="{91240B29-F687-4f45-9708-019B960494DF}">
-                  <a14:hiddenLine xmlns="" xmlns:a14="http://schemas.microsoft.com/office/drawing/2010/main" w="9525">
+                  <a14:hiddenLine xmlns:a14="http://schemas.microsoft.com/office/drawing/2010/main" xmlns="" w="9525">
                     <a:solidFill>
                       <a:srgbClr val="000000"/>
                     </a:solidFill>
@@ -9785,7 +9786,7 @@
               </a:ln>
               <a:extLst>
                 <a:ext uri="{91240B29-F687-4f45-9708-019B960494DF}">
-                  <a14:hiddenLine xmlns="" xmlns:a14="http://schemas.microsoft.com/office/drawing/2010/main" w="9525">
+                  <a14:hiddenLine xmlns:a14="http://schemas.microsoft.com/office/drawing/2010/main" xmlns="" w="9525">
                     <a:solidFill>
                       <a:srgbClr val="000000"/>
                     </a:solidFill>
@@ -9847,7 +9848,7 @@
               </a:ln>
               <a:extLst>
                 <a:ext uri="{91240B29-F687-4f45-9708-019B960494DF}">
-                  <a14:hiddenLine xmlns="" xmlns:a14="http://schemas.microsoft.com/office/drawing/2010/main" w="9525">
+                  <a14:hiddenLine xmlns:a14="http://schemas.microsoft.com/office/drawing/2010/main" xmlns="" w="9525">
                     <a:solidFill>
                       <a:srgbClr val="000000"/>
                     </a:solidFill>
@@ -9937,7 +9938,7 @@
               </a:ln>
               <a:extLst>
                 <a:ext uri="{91240B29-F687-4f45-9708-019B960494DF}">
-                  <a14:hiddenLine xmlns="" xmlns:a14="http://schemas.microsoft.com/office/drawing/2010/main" w="9525">
+                  <a14:hiddenLine xmlns:a14="http://schemas.microsoft.com/office/drawing/2010/main" xmlns="" w="9525">
                     <a:solidFill>
                       <a:srgbClr val="000000"/>
                     </a:solidFill>
@@ -9999,7 +10000,7 @@
               </a:ln>
               <a:extLst>
                 <a:ext uri="{91240B29-F687-4f45-9708-019B960494DF}">
-                  <a14:hiddenLine xmlns="" xmlns:a14="http://schemas.microsoft.com/office/drawing/2010/main" w="9525">
+                  <a14:hiddenLine xmlns:a14="http://schemas.microsoft.com/office/drawing/2010/main" xmlns="" w="9525">
                     <a:solidFill>
                       <a:srgbClr val="000000"/>
                     </a:solidFill>
@@ -10061,7 +10062,7 @@
               </a:ln>
               <a:extLst>
                 <a:ext uri="{91240B29-F687-4f45-9708-019B960494DF}">
-                  <a14:hiddenLine xmlns="" xmlns:a14="http://schemas.microsoft.com/office/drawing/2010/main" w="9525">
+                  <a14:hiddenLine xmlns:a14="http://schemas.microsoft.com/office/drawing/2010/main" xmlns="" w="9525">
                     <a:solidFill>
                       <a:srgbClr val="000000"/>
                     </a:solidFill>
@@ -10151,7 +10152,7 @@
               </a:ln>
               <a:extLst>
                 <a:ext uri="{91240B29-F687-4f45-9708-019B960494DF}">
-                  <a14:hiddenLine xmlns="" xmlns:a14="http://schemas.microsoft.com/office/drawing/2010/main" w="9525">
+                  <a14:hiddenLine xmlns:a14="http://schemas.microsoft.com/office/drawing/2010/main" xmlns="" w="9525">
                     <a:solidFill>
                       <a:srgbClr val="000000"/>
                     </a:solidFill>
@@ -10241,7 +10242,7 @@
               </a:ln>
               <a:extLst>
                 <a:ext uri="{91240B29-F687-4f45-9708-019B960494DF}">
-                  <a14:hiddenLine xmlns="" xmlns:a14="http://schemas.microsoft.com/office/drawing/2010/main" w="9525">
+                  <a14:hiddenLine xmlns:a14="http://schemas.microsoft.com/office/drawing/2010/main" xmlns="" w="9525">
                     <a:solidFill>
                       <a:srgbClr val="000000"/>
                     </a:solidFill>
@@ -10303,7 +10304,7 @@
               </a:ln>
               <a:extLst>
                 <a:ext uri="{91240B29-F687-4f45-9708-019B960494DF}">
-                  <a14:hiddenLine xmlns="" xmlns:a14="http://schemas.microsoft.com/office/drawing/2010/main" w="9525">
+                  <a14:hiddenLine xmlns:a14="http://schemas.microsoft.com/office/drawing/2010/main" xmlns="" w="9525">
                     <a:solidFill>
                       <a:srgbClr val="000000"/>
                     </a:solidFill>
@@ -10413,7 +10414,7 @@
               </a:ln>
               <a:extLst>
                 <a:ext uri="{91240B29-F687-4f45-9708-019B960494DF}">
-                  <a14:hiddenLine xmlns="" xmlns:a14="http://schemas.microsoft.com/office/drawing/2010/main" w="9525">
+                  <a14:hiddenLine xmlns:a14="http://schemas.microsoft.com/office/drawing/2010/main" xmlns="" w="9525">
                     <a:solidFill>
                       <a:srgbClr val="000000"/>
                     </a:solidFill>
@@ -10497,7 +10498,7 @@
               </a:ln>
               <a:extLst>
                 <a:ext uri="{91240B29-F687-4f45-9708-019B960494DF}">
-                  <a14:hiddenLine xmlns="" xmlns:a14="http://schemas.microsoft.com/office/drawing/2010/main" w="9525">
+                  <a14:hiddenLine xmlns:a14="http://schemas.microsoft.com/office/drawing/2010/main" xmlns="" w="9525">
                     <a:solidFill>
                       <a:srgbClr val="000000"/>
                     </a:solidFill>
@@ -10559,7 +10560,7 @@
               </a:ln>
               <a:extLst>
                 <a:ext uri="{91240B29-F687-4f45-9708-019B960494DF}">
-                  <a14:hiddenLine xmlns="" xmlns:a14="http://schemas.microsoft.com/office/drawing/2010/main" w="9525">
+                  <a14:hiddenLine xmlns:a14="http://schemas.microsoft.com/office/drawing/2010/main" xmlns="" w="9525">
                     <a:solidFill>
                       <a:srgbClr val="000000"/>
                     </a:solidFill>
@@ -10621,7 +10622,7 @@
               </a:ln>
               <a:extLst>
                 <a:ext uri="{91240B29-F687-4f45-9708-019B960494DF}">
-                  <a14:hiddenLine xmlns="" xmlns:a14="http://schemas.microsoft.com/office/drawing/2010/main" w="9525">
+                  <a14:hiddenLine xmlns:a14="http://schemas.microsoft.com/office/drawing/2010/main" xmlns="" w="9525">
                     <a:solidFill>
                       <a:srgbClr val="000000"/>
                     </a:solidFill>
@@ -10711,7 +10712,7 @@
               </a:ln>
               <a:extLst>
                 <a:ext uri="{91240B29-F687-4f45-9708-019B960494DF}">
-                  <a14:hiddenLine xmlns="" xmlns:a14="http://schemas.microsoft.com/office/drawing/2010/main" w="9525">
+                  <a14:hiddenLine xmlns:a14="http://schemas.microsoft.com/office/drawing/2010/main" xmlns="" w="9525">
                     <a:solidFill>
                       <a:srgbClr val="000000"/>
                     </a:solidFill>
@@ -10745,7 +10746,7 @@
               </a:ln>
               <a:extLst>
                 <a:ext uri="{91240B29-F687-4f45-9708-019B960494DF}">
-                  <a14:hiddenLine xmlns="" xmlns:a14="http://schemas.microsoft.com/office/drawing/2010/main" w="9525">
+                  <a14:hiddenLine xmlns:a14="http://schemas.microsoft.com/office/drawing/2010/main" xmlns="" w="9525">
                     <a:solidFill>
                       <a:srgbClr val="000000"/>
                     </a:solidFill>
@@ -10810,7 +10811,7 @@
               </a:ln>
               <a:extLst>
                 <a:ext uri="{91240B29-F687-4f45-9708-019B960494DF}">
-                  <a14:hiddenLine xmlns="" xmlns:a14="http://schemas.microsoft.com/office/drawing/2010/main" w="9525">
+                  <a14:hiddenLine xmlns:a14="http://schemas.microsoft.com/office/drawing/2010/main" xmlns="" w="9525">
                     <a:solidFill>
                       <a:srgbClr val="000000"/>
                     </a:solidFill>
@@ -10900,7 +10901,7 @@
               </a:ln>
               <a:extLst>
                 <a:ext uri="{91240B29-F687-4f45-9708-019B960494DF}">
-                  <a14:hiddenLine xmlns="" xmlns:a14="http://schemas.microsoft.com/office/drawing/2010/main" w="9525">
+                  <a14:hiddenLine xmlns:a14="http://schemas.microsoft.com/office/drawing/2010/main" xmlns="" w="9525">
                     <a:solidFill>
                       <a:srgbClr val="000000"/>
                     </a:solidFill>
@@ -10962,7 +10963,7 @@
               </a:ln>
               <a:extLst>
                 <a:ext uri="{91240B29-F687-4f45-9708-019B960494DF}">
-                  <a14:hiddenLine xmlns="" xmlns:a14="http://schemas.microsoft.com/office/drawing/2010/main" w="9525">
+                  <a14:hiddenLine xmlns:a14="http://schemas.microsoft.com/office/drawing/2010/main" xmlns="" w="9525">
                     <a:solidFill>
                       <a:srgbClr val="000000"/>
                     </a:solidFill>
@@ -11052,7 +11053,7 @@
               </a:ln>
               <a:extLst>
                 <a:ext uri="{91240B29-F687-4f45-9708-019B960494DF}">
-                  <a14:hiddenLine xmlns="" xmlns:a14="http://schemas.microsoft.com/office/drawing/2010/main" w="9525">
+                  <a14:hiddenLine xmlns:a14="http://schemas.microsoft.com/office/drawing/2010/main" xmlns="" w="9525">
                     <a:solidFill>
                       <a:srgbClr val="000000"/>
                     </a:solidFill>
@@ -11117,7 +11118,7 @@
               </a:ln>
               <a:extLst>
                 <a:ext uri="{91240B29-F687-4f45-9708-019B960494DF}">
-                  <a14:hiddenLine xmlns="" xmlns:a14="http://schemas.microsoft.com/office/drawing/2010/main" w="9525">
+                  <a14:hiddenLine xmlns:a14="http://schemas.microsoft.com/office/drawing/2010/main" xmlns="" w="9525">
                     <a:solidFill>
                       <a:srgbClr val="000000"/>
                     </a:solidFill>
@@ -11179,7 +11180,7 @@
               </a:ln>
               <a:extLst>
                 <a:ext uri="{91240B29-F687-4f45-9708-019B960494DF}">
-                  <a14:hiddenLine xmlns="" xmlns:a14="http://schemas.microsoft.com/office/drawing/2010/main" w="9525">
+                  <a14:hiddenLine xmlns:a14="http://schemas.microsoft.com/office/drawing/2010/main" xmlns="" w="9525">
                     <a:solidFill>
                       <a:srgbClr val="000000"/>
                     </a:solidFill>
@@ -11269,7 +11270,7 @@
               </a:ln>
               <a:extLst>
                 <a:ext uri="{91240B29-F687-4f45-9708-019B960494DF}">
-                  <a14:hiddenLine xmlns="" xmlns:a14="http://schemas.microsoft.com/office/drawing/2010/main" w="9525">
+                  <a14:hiddenLine xmlns:a14="http://schemas.microsoft.com/office/drawing/2010/main" xmlns="" w="9525">
                     <a:solidFill>
                       <a:srgbClr val="000000"/>
                     </a:solidFill>
@@ -11359,7 +11360,7 @@
               </a:ln>
               <a:extLst>
                 <a:ext uri="{91240B29-F687-4f45-9708-019B960494DF}">
-                  <a14:hiddenLine xmlns="" xmlns:a14="http://schemas.microsoft.com/office/drawing/2010/main" w="9525">
+                  <a14:hiddenLine xmlns:a14="http://schemas.microsoft.com/office/drawing/2010/main" xmlns="" w="9525">
                     <a:solidFill>
                       <a:srgbClr val="000000"/>
                     </a:solidFill>
@@ -11424,7 +11425,7 @@
               </a:ln>
               <a:extLst>
                 <a:ext uri="{91240B29-F687-4f45-9708-019B960494DF}">
-                  <a14:hiddenLine xmlns="" xmlns:a14="http://schemas.microsoft.com/office/drawing/2010/main" w="9525">
+                  <a14:hiddenLine xmlns:a14="http://schemas.microsoft.com/office/drawing/2010/main" xmlns="" w="9525">
                     <a:solidFill>
                       <a:srgbClr val="000000"/>
                     </a:solidFill>
@@ -11544,7 +11545,7 @@
               </a:ln>
               <a:extLst>
                 <a:ext uri="{91240B29-F687-4f45-9708-019B960494DF}">
-                  <a14:hiddenLine xmlns="" xmlns:a14="http://schemas.microsoft.com/office/drawing/2010/main" w="9525">
+                  <a14:hiddenLine xmlns:a14="http://schemas.microsoft.com/office/drawing/2010/main" xmlns="" w="9525">
                     <a:solidFill>
                       <a:srgbClr val="000000"/>
                     </a:solidFill>
@@ -11625,7 +11626,7 @@
               </a:ln>
               <a:extLst>
                 <a:ext uri="{91240B29-F687-4f45-9708-019B960494DF}">
-                  <a14:hiddenLine xmlns="" xmlns:a14="http://schemas.microsoft.com/office/drawing/2010/main" w="9525">
+                  <a14:hiddenLine xmlns:a14="http://schemas.microsoft.com/office/drawing/2010/main" xmlns="" w="9525">
                     <a:solidFill>
                       <a:srgbClr val="000000"/>
                     </a:solidFill>
@@ -11740,7 +11741,7 @@
               </a:ln>
               <a:extLst>
                 <a:ext uri="{91240B29-F687-4f45-9708-019B960494DF}">
-                  <a14:hiddenLine xmlns="" xmlns:a14="http://schemas.microsoft.com/office/drawing/2010/main" w="9525">
+                  <a14:hiddenLine xmlns:a14="http://schemas.microsoft.com/office/drawing/2010/main" xmlns="" w="9525">
                     <a:solidFill>
                       <a:srgbClr val="000000"/>
                     </a:solidFill>
@@ -11830,7 +11831,7 @@
               </a:ln>
               <a:extLst>
                 <a:ext uri="{91240B29-F687-4f45-9708-019B960494DF}">
-                  <a14:hiddenLine xmlns="" xmlns:a14="http://schemas.microsoft.com/office/drawing/2010/main" w="9525">
+                  <a14:hiddenLine xmlns:a14="http://schemas.microsoft.com/office/drawing/2010/main" xmlns="" w="9525">
                     <a:solidFill>
                       <a:srgbClr val="000000"/>
                     </a:solidFill>
@@ -11895,7 +11896,7 @@
               </a:ln>
               <a:extLst>
                 <a:ext uri="{91240B29-F687-4f45-9708-019B960494DF}">
-                  <a14:hiddenLine xmlns="" xmlns:a14="http://schemas.microsoft.com/office/drawing/2010/main" w="9525">
+                  <a14:hiddenLine xmlns:a14="http://schemas.microsoft.com/office/drawing/2010/main" xmlns="" w="9525">
                     <a:solidFill>
                       <a:srgbClr val="000000"/>
                     </a:solidFill>
@@ -11985,7 +11986,7 @@
               </a:ln>
               <a:extLst>
                 <a:ext uri="{91240B29-F687-4f45-9708-019B960494DF}">
-                  <a14:hiddenLine xmlns="" xmlns:a14="http://schemas.microsoft.com/office/drawing/2010/main" w="9525">
+                  <a14:hiddenLine xmlns:a14="http://schemas.microsoft.com/office/drawing/2010/main" xmlns="" w="9525">
                     <a:solidFill>
                       <a:srgbClr val="000000"/>
                     </a:solidFill>
@@ -12053,7 +12054,7 @@
               </a:ln>
               <a:extLst>
                 <a:ext uri="{91240B29-F687-4f45-9708-019B960494DF}">
-                  <a14:hiddenLine xmlns="" xmlns:a14="http://schemas.microsoft.com/office/drawing/2010/main" w="9525">
+                  <a14:hiddenLine xmlns:a14="http://schemas.microsoft.com/office/drawing/2010/main" xmlns="" w="9525">
                     <a:solidFill>
                       <a:srgbClr val="000000"/>
                     </a:solidFill>
@@ -12143,7 +12144,7 @@
               </a:ln>
               <a:extLst>
                 <a:ext uri="{91240B29-F687-4f45-9708-019B960494DF}">
-                  <a14:hiddenLine xmlns="" xmlns:a14="http://schemas.microsoft.com/office/drawing/2010/main" w="9525">
+                  <a14:hiddenLine xmlns:a14="http://schemas.microsoft.com/office/drawing/2010/main" xmlns="" w="9525">
                     <a:solidFill>
                       <a:srgbClr val="000000"/>
                     </a:solidFill>
@@ -12211,7 +12212,7 @@
               </a:ln>
               <a:extLst>
                 <a:ext uri="{91240B29-F687-4f45-9708-019B960494DF}">
-                  <a14:hiddenLine xmlns="" xmlns:a14="http://schemas.microsoft.com/office/drawing/2010/main" w="9525">
+                  <a14:hiddenLine xmlns:a14="http://schemas.microsoft.com/office/drawing/2010/main" xmlns="" w="9525">
                     <a:solidFill>
                       <a:srgbClr val="000000"/>
                     </a:solidFill>
@@ -12301,7 +12302,7 @@
               </a:ln>
               <a:extLst>
                 <a:ext uri="{91240B29-F687-4f45-9708-019B960494DF}">
-                  <a14:hiddenLine xmlns="" xmlns:a14="http://schemas.microsoft.com/office/drawing/2010/main" w="9525">
+                  <a14:hiddenLine xmlns:a14="http://schemas.microsoft.com/office/drawing/2010/main" xmlns="" w="9525">
                     <a:solidFill>
                       <a:srgbClr val="000000"/>
                     </a:solidFill>
@@ -12335,7 +12336,7 @@
               </a:ln>
               <a:extLst>
                 <a:ext uri="{91240B29-F687-4f45-9708-019B960494DF}">
-                  <a14:hiddenLine xmlns="" xmlns:a14="http://schemas.microsoft.com/office/drawing/2010/main" w="9525">
+                  <a14:hiddenLine xmlns:a14="http://schemas.microsoft.com/office/drawing/2010/main" xmlns="" w="9525">
                     <a:solidFill>
                       <a:srgbClr val="000000"/>
                     </a:solidFill>
@@ -12475,7 +12476,7 @@
           <a:p>
             <a:fld id="{92FF8978-FE14-CC4A-93A6-934EB06543C0}" type="datetime1">
               <a:rPr lang="en-US" smtClean="0"/>
-              <a:t>9/24/26</a:t>
+              <a:t>9/28/26</a:t>
             </a:fld>
             <a:endParaRPr lang="en-US"/>
           </a:p>
@@ -13773,6 +13774,288 @@
   <p:cSld>
     <p:spTree>
       <p:nvGrpSpPr>
+        <p:cNvPr id="1" name="">
+          <a:extLst>
+            <a:ext uri="{FF2B5EF4-FFF2-40B4-BE49-F238E27FC236}">
+              <a16:creationId xmlns:a16="http://schemas.microsoft.com/office/drawing/2014/main" id="{7827E86E-46F1-D49E-DD52-52080C80B0BB}"/>
+            </a:ext>
+          </a:extLst>
+        </p:cNvPr>
+        <p:cNvGrpSpPr/>
+        <p:nvPr/>
+      </p:nvGrpSpPr>
+      <p:grpSpPr>
+        <a:xfrm>
+          <a:off x="0" y="0"/>
+          <a:ext cx="0" cy="0"/>
+          <a:chOff x="0" y="0"/>
+          <a:chExt cx="0" cy="0"/>
+        </a:xfrm>
+      </p:grpSpPr>
+      <p:sp>
+        <p:nvSpPr>
+          <p:cNvPr id="6146" name="Rectangle 2">
+            <a:extLst>
+              <a:ext uri="{FF2B5EF4-FFF2-40B4-BE49-F238E27FC236}">
+                <a16:creationId xmlns:a16="http://schemas.microsoft.com/office/drawing/2014/main" id="{B59EEE50-39CE-F54C-CEF6-D1A30575F7A4}"/>
+              </a:ext>
+            </a:extLst>
+          </p:cNvPr>
+          <p:cNvSpPr>
+            <a:spLocks noGrp="1" noChangeArrowheads="1"/>
+          </p:cNvSpPr>
+          <p:nvPr>
+            <p:ph type="title"/>
+            <p:custDataLst>
+              <p:tags r:id="rId1"/>
+            </p:custDataLst>
+          </p:nvPr>
+        </p:nvSpPr>
+        <p:spPr>
+          <a:xfrm>
+            <a:off x="1141413" y="284084"/>
+            <a:ext cx="9905998" cy="620791"/>
+          </a:xfrm>
+        </p:spPr>
+        <p:txBody>
+          <a:bodyPr/>
+          <a:lstStyle/>
+          <a:p>
+            <a:pPr algn="ctr"/>
+            <a:r>
+              <a:rPr lang="en-US" dirty="0"/>
+              <a:t>Lecture 11 - Tuesday, Sep. 28</a:t>
+            </a:r>
+          </a:p>
+        </p:txBody>
+      </p:sp>
+      <p:sp>
+        <p:nvSpPr>
+          <p:cNvPr id="6147" name="Rectangle 3">
+            <a:extLst>
+              <a:ext uri="{FF2B5EF4-FFF2-40B4-BE49-F238E27FC236}">
+                <a16:creationId xmlns:a16="http://schemas.microsoft.com/office/drawing/2014/main" id="{5212EBB3-5733-042E-DCB3-686852125871}"/>
+              </a:ext>
+            </a:extLst>
+          </p:cNvPr>
+          <p:cNvSpPr>
+            <a:spLocks noGrp="1" noChangeArrowheads="1"/>
+          </p:cNvSpPr>
+          <p:nvPr>
+            <p:ph idx="1"/>
+            <p:custDataLst>
+              <p:tags r:id="rId2"/>
+            </p:custDataLst>
+          </p:nvPr>
+        </p:nvSpPr>
+        <p:spPr>
+          <a:xfrm>
+            <a:off x="1294151" y="1098548"/>
+            <a:ext cx="9600522" cy="5475367"/>
+          </a:xfrm>
+        </p:spPr>
+        <p:txBody>
+          <a:bodyPr>
+            <a:normAutofit fontScale="70000" lnSpcReduction="20000"/>
+          </a:bodyPr>
+          <a:lstStyle/>
+          <a:p>
+            <a:r>
+              <a:rPr lang="en-US" dirty="0">
+                <a:latin typeface="Arial" panose="020B0604020202020204" pitchFamily="34" charset="0"/>
+                <a:cs typeface="Arial" panose="020B0604020202020204" pitchFamily="34" charset="0"/>
+              </a:rPr>
+              <a:t>Please remember </a:t>
+            </a:r>
+            <a:r>
+              <a:rPr lang="en-US" b="1" i="1" u="sng" dirty="0">
+                <a:latin typeface="Arial" panose="020B0604020202020204" pitchFamily="34" charset="0"/>
+                <a:cs typeface="Arial" panose="020B0604020202020204" pitchFamily="34" charset="0"/>
+              </a:rPr>
+              <a:t>no laptops / phones</a:t>
+            </a:r>
+            <a:r>
+              <a:rPr lang="en-US" dirty="0">
+                <a:latin typeface="Arial" panose="020B0604020202020204" pitchFamily="34" charset="0"/>
+                <a:cs typeface="Arial" panose="020B0604020202020204" pitchFamily="34" charset="0"/>
+              </a:rPr>
+              <a:t> and </a:t>
+            </a:r>
+            <a:r>
+              <a:rPr lang="en-US" b="1" i="1" u="sng" dirty="0">
+                <a:latin typeface="Arial" panose="020B0604020202020204" pitchFamily="34" charset="0"/>
+                <a:cs typeface="Arial" panose="020B0604020202020204" pitchFamily="34" charset="0"/>
+              </a:rPr>
+              <a:t>attendance policy</a:t>
+            </a:r>
+            <a:endParaRPr lang="en-US" dirty="0">
+              <a:latin typeface="Arial" panose="020B0604020202020204" pitchFamily="34" charset="0"/>
+              <a:cs typeface="Arial" panose="020B0604020202020204" pitchFamily="34" charset="0"/>
+            </a:endParaRPr>
+          </a:p>
+          <a:p>
+            <a:r>
+              <a:rPr lang="en-US" dirty="0">
+                <a:latin typeface="Arial" panose="020B0604020202020204" pitchFamily="34" charset="0"/>
+                <a:cs typeface="Arial" panose="020B0604020202020204" pitchFamily="34" charset="0"/>
+              </a:rPr>
+              <a:t>This week:</a:t>
+            </a:r>
+          </a:p>
+          <a:p>
+            <a:pPr lvl="1"/>
+            <a:r>
+              <a:rPr lang="en-US" dirty="0">
+                <a:latin typeface="Arial" panose="020B0604020202020204" pitchFamily="34" charset="0"/>
+                <a:cs typeface="Arial" panose="020B0604020202020204" pitchFamily="34" charset="0"/>
+              </a:rPr>
+              <a:t>Mod 2 written assignment is due on Thursday!</a:t>
+            </a:r>
+          </a:p>
+          <a:p>
+            <a:pPr lvl="1"/>
+            <a:r>
+              <a:rPr lang="en-US" dirty="0">
+                <a:latin typeface="Arial" panose="020B0604020202020204" pitchFamily="34" charset="0"/>
+                <a:cs typeface="Arial" panose="020B0604020202020204" pitchFamily="34" charset="0"/>
+              </a:rPr>
+              <a:t>Fall break is next week (woohoo!)</a:t>
+            </a:r>
+          </a:p>
+          <a:p>
+            <a:r>
+              <a:rPr lang="en-US" dirty="0">
+                <a:latin typeface="Arial" panose="020B0604020202020204" pitchFamily="34" charset="0"/>
+                <a:cs typeface="Arial" panose="020B0604020202020204" pitchFamily="34" charset="0"/>
+              </a:rPr>
+              <a:t>Module 1 Quiz</a:t>
+            </a:r>
+          </a:p>
+          <a:p>
+            <a:pPr lvl="1"/>
+            <a:r>
+              <a:rPr lang="en-US" dirty="0">
+                <a:latin typeface="Arial" panose="020B0604020202020204" pitchFamily="34" charset="0"/>
+                <a:cs typeface="Arial" panose="020B0604020202020204" pitchFamily="34" charset="0"/>
+              </a:rPr>
+              <a:t>Being graded right now. Will release on Thursday.</a:t>
+            </a:r>
+          </a:p>
+          <a:p>
+            <a:pPr lvl="1"/>
+            <a:r>
+              <a:rPr lang="en-US" dirty="0">
+                <a:latin typeface="Arial" panose="020B0604020202020204" pitchFamily="34" charset="0"/>
+                <a:cs typeface="Arial" panose="020B0604020202020204" pitchFamily="34" charset="0"/>
+              </a:rPr>
+              <a:t>I’m making an adjustment to the DFA question grades due to the “delete” issue</a:t>
+            </a:r>
+          </a:p>
+          <a:p>
+            <a:pPr lvl="2"/>
+            <a:r>
+              <a:rPr lang="en-US" dirty="0">
+                <a:latin typeface="Arial" panose="020B0604020202020204" pitchFamily="34" charset="0"/>
+                <a:cs typeface="Arial" panose="020B0604020202020204" pitchFamily="34" charset="0"/>
+              </a:rPr>
+              <a:t>Both of your DFA scores will be set to the max of your DFA scores.</a:t>
+            </a:r>
+          </a:p>
+          <a:p>
+            <a:r>
+              <a:rPr lang="en-US" dirty="0">
+                <a:latin typeface="Arial" panose="020B0604020202020204" pitchFamily="34" charset="0"/>
+                <a:cs typeface="Arial" panose="020B0604020202020204" pitchFamily="34" charset="0"/>
+              </a:rPr>
+              <a:t>Mod. 1 homework is being graded right now. </a:t>
+            </a:r>
+          </a:p>
+          <a:p>
+            <a:pPr lvl="1"/>
+            <a:r>
+              <a:rPr lang="en-US" dirty="0">
+                <a:latin typeface="Arial" panose="020B0604020202020204" pitchFamily="34" charset="0"/>
+                <a:cs typeface="Arial" panose="020B0604020202020204" pitchFamily="34" charset="0"/>
+              </a:rPr>
+              <a:t>Should be able to get that back to you shortly…</a:t>
+            </a:r>
+          </a:p>
+          <a:p>
+            <a:r>
+              <a:rPr lang="en-US" dirty="0">
+                <a:latin typeface="Arial" panose="020B0604020202020204" pitchFamily="34" charset="0"/>
+                <a:cs typeface="Arial" panose="020B0604020202020204" pitchFamily="34" charset="0"/>
+              </a:rPr>
+              <a:t>Quiz 2</a:t>
+            </a:r>
+          </a:p>
+          <a:p>
+            <a:pPr lvl="1"/>
+            <a:r>
+              <a:rPr lang="en-US" dirty="0">
+                <a:latin typeface="Arial" panose="020B0604020202020204" pitchFamily="34" charset="0"/>
+                <a:cs typeface="Arial" panose="020B0604020202020204" pitchFamily="34" charset="0"/>
+              </a:rPr>
+              <a:t>Is in two weeks! You will start signing up for your reservations for this NEXT week.</a:t>
+            </a:r>
+          </a:p>
+          <a:p>
+            <a:r>
+              <a:rPr lang="en-US" dirty="0">
+                <a:latin typeface="Arial" panose="020B0604020202020204" pitchFamily="34" charset="0"/>
+                <a:cs typeface="Arial" panose="020B0604020202020204" pitchFamily="34" charset="0"/>
+              </a:rPr>
+              <a:t>OH Check-Ins</a:t>
+            </a:r>
+          </a:p>
+          <a:p>
+            <a:pPr lvl="1"/>
+            <a:r>
+              <a:rPr lang="en-US" dirty="0">
+                <a:latin typeface="Arial" panose="020B0604020202020204" pitchFamily="34" charset="0"/>
+                <a:cs typeface="Arial" panose="020B0604020202020204" pitchFamily="34" charset="0"/>
+              </a:rPr>
+              <a:t>This is shaping up but I won’t have more concrete information until next week!</a:t>
+            </a:r>
+          </a:p>
+          <a:p>
+            <a:r>
+              <a:rPr lang="en-US" dirty="0">
+                <a:latin typeface="Arial" panose="020B0604020202020204" pitchFamily="34" charset="0"/>
+                <a:cs typeface="Arial" panose="020B0604020202020204" pitchFamily="34" charset="0"/>
+              </a:rPr>
+              <a:t>These slides are linked on the course webpage “slides” page.</a:t>
+            </a:r>
+          </a:p>
+          <a:p>
+            <a:r>
+              <a:rPr lang="en-US" dirty="0">
+                <a:latin typeface="Arial" panose="020B0604020202020204" pitchFamily="34" charset="0"/>
+                <a:cs typeface="Arial" panose="020B0604020202020204" pitchFamily="34" charset="0"/>
+              </a:rPr>
+              <a:t>Today we will continue with Module 2 – Context-Free Grammars.</a:t>
+            </a:r>
+          </a:p>
+        </p:txBody>
+      </p:sp>
+    </p:spTree>
+    <p:extLst>
+      <p:ext uri="{BB962C8B-B14F-4D97-AF65-F5344CB8AC3E}">
+        <p14:creationId xmlns:p14="http://schemas.microsoft.com/office/powerpoint/2010/main" val="3257908011"/>
+      </p:ext>
+    </p:extLst>
+  </p:cSld>
+  <p:clrMapOvr>
+    <a:masterClrMapping/>
+  </p:clrMapOvr>
+</p:sld>
+</file>
+
+<file path=ppt/slides/slide14.xml><?xml version="1.0" encoding="utf-8"?>
+<p:sld xmlns:a="http://schemas.openxmlformats.org/drawingml/2006/main" xmlns:r="http://schemas.openxmlformats.org/officeDocument/2006/relationships" xmlns:p="http://schemas.openxmlformats.org/presentationml/2006/main">
+  <p:cSld>
+    <p:spTree>
+      <p:nvGrpSpPr>
         <p:cNvPr id="1" name=""/>
         <p:cNvGrpSpPr/>
         <p:nvPr/>
@@ -14109,7 +14392,7 @@
           <p:nvPr>
             <p:extLst>
               <p:ext uri="{D42A27DB-BD31-4B8C-83A1-F6EECF244321}">
-                <p14:modId xmlns:p14="http://schemas.microsoft.com/office/powerpoint/2010/main" val="1470152519"/>
+                <p14:modId xmlns:p14="http://schemas.microsoft.com/office/powerpoint/2010/main" val="1641075703"/>
               </p:ext>
             </p:extLst>
           </p:nvPr>
@@ -14205,7 +14488,7 @@
                       <a:pPr algn="ctr"/>
                       <a:r>
                         <a:rPr lang="en-US" i="0" dirty="0"/>
-                        <a:t>9</a:t>
+                        <a:t>10</a:t>
                       </a:r>
                     </a:p>
                   </a:txBody>
@@ -14219,7 +14502,7 @@
                       <a:pPr algn="ctr"/>
                       <a:r>
                         <a:rPr lang="en-US" i="0" dirty="0"/>
-                        <a:t>9</a:t>
+                        <a:t>10</a:t>
                       </a:r>
                     </a:p>
                   </a:txBody>
@@ -14264,7 +14547,7 @@
           <p:nvPr>
             <p:extLst>
               <p:ext uri="{D42A27DB-BD31-4B8C-83A1-F6EECF244321}">
-                <p14:modId xmlns:p14="http://schemas.microsoft.com/office/powerpoint/2010/main" val="287354998"/>
+                <p14:modId xmlns:p14="http://schemas.microsoft.com/office/powerpoint/2010/main" val="1942536635"/>
               </p:ext>
             </p:extLst>
           </p:nvPr>
@@ -14523,7 +14806,7 @@
                       <a:pPr algn="ctr"/>
                       <a:r>
                         <a:rPr lang="en-US" dirty="0"/>
-                        <a:t>-</a:t>
+                        <a:t>116</a:t>
                       </a:r>
                     </a:p>
                   </a:txBody>
@@ -15064,7 +15347,7 @@
           <p:nvPr>
             <p:extLst>
               <p:ext uri="{D42A27DB-BD31-4B8C-83A1-F6EECF244321}">
-                <p14:modId xmlns:p14="http://schemas.microsoft.com/office/powerpoint/2010/main" val="3741389918"/>
+                <p14:modId xmlns:p14="http://schemas.microsoft.com/office/powerpoint/2010/main" val="2441303257"/>
               </p:ext>
             </p:extLst>
           </p:nvPr>
@@ -15160,7 +15443,7 @@
                       <a:pPr algn="ctr"/>
                       <a:r>
                         <a:rPr lang="en-US" i="0" dirty="0"/>
-                        <a:t>4</a:t>
+                        <a:t>5</a:t>
                       </a:r>
                     </a:p>
                   </a:txBody>
@@ -15174,7 +15457,7 @@
                       <a:pPr algn="ctr"/>
                       <a:r>
                         <a:rPr lang="en-US" i="0" dirty="0"/>
-                        <a:t>4</a:t>
+                        <a:t>5</a:t>
                       </a:r>
                     </a:p>
                   </a:txBody>
@@ -15452,7 +15735,7 @@
           <p:nvPr>
             <p:extLst>
               <p:ext uri="{D42A27DB-BD31-4B8C-83A1-F6EECF244321}">
-                <p14:modId xmlns:p14="http://schemas.microsoft.com/office/powerpoint/2010/main" val="2330738710"/>
+                <p14:modId xmlns:p14="http://schemas.microsoft.com/office/powerpoint/2010/main" val="2711374298"/>
               </p:ext>
             </p:extLst>
           </p:nvPr>
@@ -15548,7 +15831,7 @@
                       <a:pPr algn="ctr"/>
                       <a:r>
                         <a:rPr lang="en-US" i="0" dirty="0"/>
-                        <a:t>9</a:t>
+                        <a:t>10</a:t>
                       </a:r>
                     </a:p>
                   </a:txBody>
@@ -15562,7 +15845,7 @@
                       <a:pPr algn="ctr"/>
                       <a:r>
                         <a:rPr lang="en-US" i="0" dirty="0"/>
-                        <a:t>9</a:t>
+                        <a:t>10</a:t>
                       </a:r>
                     </a:p>
                   </a:txBody>
@@ -15833,7 +16116,7 @@
           <p:nvPr>
             <p:extLst>
               <p:ext uri="{D42A27DB-BD31-4B8C-83A1-F6EECF244321}">
-                <p14:modId xmlns:p14="http://schemas.microsoft.com/office/powerpoint/2010/main" val="2995271694"/>
+                <p14:modId xmlns:p14="http://schemas.microsoft.com/office/powerpoint/2010/main" val="2214872950"/>
               </p:ext>
             </p:extLst>
           </p:nvPr>
@@ -15929,7 +16212,7 @@
                       <a:pPr algn="ctr"/>
                       <a:r>
                         <a:rPr lang="en-US" i="0" dirty="0"/>
-                        <a:t>4</a:t>
+                        <a:t>5</a:t>
                       </a:r>
                     </a:p>
                   </a:txBody>
@@ -15943,7 +16226,7 @@
                       <a:pPr algn="ctr"/>
                       <a:r>
                         <a:rPr lang="en-US" i="0" dirty="0"/>
-                        <a:t>4</a:t>
+                        <a:t>5</a:t>
                       </a:r>
                     </a:p>
                   </a:txBody>
@@ -18120,7 +18403,19 @@
 </p:tagLst>
 </file>
 
+<file path=ppt/tags/tag29.xml><?xml version="1.0" encoding="utf-8"?>
+<p:tagLst xmlns:a="http://schemas.openxmlformats.org/drawingml/2006/main" xmlns:r="http://schemas.openxmlformats.org/officeDocument/2006/relationships" xmlns:p="http://schemas.openxmlformats.org/presentationml/2006/main">
+  <p:tag name="_INSTRUCTOR VIEW19C14C36-AC8E-43BC-9DB6-C2AAF774C7DC|PANE__TAG" val="_"/>
+</p:tagLst>
+</file>
+
 <file path=ppt/tags/tag3.xml><?xml version="1.0" encoding="utf-8"?>
+<p:tagLst xmlns:a="http://schemas.openxmlformats.org/drawingml/2006/main" xmlns:r="http://schemas.openxmlformats.org/officeDocument/2006/relationships" xmlns:p="http://schemas.openxmlformats.org/presentationml/2006/main">
+  <p:tag name="_INSTRUCTOR VIEW19C14C36-AC8E-43BC-9DB6-C2AAF774C7DC|PANE__TAG" val="_"/>
+</p:tagLst>
+</file>
+
+<file path=ppt/tags/tag30.xml><?xml version="1.0" encoding="utf-8"?>
 <p:tagLst xmlns:a="http://schemas.openxmlformats.org/drawingml/2006/main" xmlns:r="http://schemas.openxmlformats.org/officeDocument/2006/relationships" xmlns:p="http://schemas.openxmlformats.org/presentationml/2006/main">
   <p:tag name="_INSTRUCTOR VIEW19C14C36-AC8E-43BC-9DB6-C2AAF774C7DC|PANE__TAG" val="_"/>
 </p:tagLst>

</xml_diff>